<commit_message>
css 수업 준비 - 05.24
</commit_message>
<xml_diff>
--- a/material/[SeSAC_YDP_6] 03_CSS_3.pptx
+++ b/material/[SeSAC_YDP_6] 03_CSS_3.pptx
@@ -5,7 +5,7 @@
     <p:sldMasterId id="2147483661" r:id="rId1"/>
   </p:sldMasterIdLst>
   <p:notesMasterIdLst>
-    <p:notesMasterId r:id="rId28"/>
+    <p:notesMasterId r:id="rId31"/>
   </p:notesMasterIdLst>
   <p:sldIdLst>
     <p:sldId id="675" r:id="rId2"/>
@@ -26,14 +26,17 @@
     <p:sldId id="687" r:id="rId17"/>
     <p:sldId id="693" r:id="rId18"/>
     <p:sldId id="314" r:id="rId19"/>
-    <p:sldId id="398" r:id="rId20"/>
-    <p:sldId id="317" r:id="rId21"/>
-    <p:sldId id="374" r:id="rId22"/>
-    <p:sldId id="375" r:id="rId23"/>
-    <p:sldId id="376" r:id="rId24"/>
-    <p:sldId id="330" r:id="rId25"/>
-    <p:sldId id="318" r:id="rId26"/>
-    <p:sldId id="319" r:id="rId27"/>
+    <p:sldId id="696" r:id="rId20"/>
+    <p:sldId id="695" r:id="rId21"/>
+    <p:sldId id="398" r:id="rId22"/>
+    <p:sldId id="694" r:id="rId23"/>
+    <p:sldId id="317" r:id="rId24"/>
+    <p:sldId id="374" r:id="rId25"/>
+    <p:sldId id="375" r:id="rId26"/>
+    <p:sldId id="376" r:id="rId27"/>
+    <p:sldId id="330" r:id="rId28"/>
+    <p:sldId id="318" r:id="rId29"/>
+    <p:sldId id="319" r:id="rId30"/>
   </p:sldIdLst>
   <p:sldSz cx="12192000" cy="6858000"/>
   <p:notesSz cx="6858000" cy="9144000"/>
@@ -222,7 +225,7 @@
           <a:p>
             <a:fld id="{00524019-D21D-4F04-AF43-2AEEE922364E}" type="datetimeFigureOut">
               <a:rPr lang="ko-KR" altLang="en-US" smtClean="0"/>
-              <a:t>2024-05-20</a:t>
+              <a:t>2024-05-24</a:t>
             </a:fld>
             <a:endParaRPr lang="ko-KR" altLang="en-US"/>
           </a:p>
@@ -1554,16 +1557,88 @@
           <a:lstStyle/>
           <a:p>
             <a:r>
-              <a:rPr lang="en-US" altLang="ko-KR" dirty="0"/>
+              <a:rPr lang="en-US" altLang="ko-KR" dirty="0" smtClean="0"/>
+              <a:t>Display</a:t>
+            </a:r>
+            <a:r>
+              <a:rPr lang="en-US" altLang="ko-KR" baseline="0" dirty="0" smtClean="0"/>
+              <a:t> </a:t>
+            </a:r>
+            <a:r>
+              <a:rPr lang="ko-KR" altLang="en-US" baseline="0" dirty="0" smtClean="0"/>
+              <a:t>속성은 </a:t>
+            </a:r>
+            <a:r>
+              <a:rPr lang="en-US" altLang="ko-KR" baseline="0" dirty="0" smtClean="0"/>
+              <a:t>HTML </a:t>
+            </a:r>
+            <a:r>
+              <a:rPr lang="ko-KR" altLang="en-US" baseline="0" dirty="0" smtClean="0"/>
+              <a:t>요소가 페이지에 어떻게 배치될지를 결정하는 아주 중요한 속성</a:t>
+            </a:r>
+            <a:endParaRPr lang="en-US" altLang="ko-KR" baseline="0" dirty="0" smtClean="0"/>
+          </a:p>
+          <a:p>
+            <a:r>
+              <a:rPr lang="ko-KR" altLang="en-US" baseline="0" dirty="0" smtClean="0"/>
+              <a:t>다양한 값이 있으며</a:t>
+            </a:r>
+            <a:r>
+              <a:rPr lang="en-US" altLang="ko-KR" baseline="0" dirty="0" smtClean="0"/>
+              <a:t>, </a:t>
+            </a:r>
+            <a:r>
+              <a:rPr lang="ko-KR" altLang="en-US" baseline="0" dirty="0" smtClean="0"/>
+              <a:t>이 값들에 따라 요소의 레이아웃 및 자식 요소의 배치가 크게 달라진다</a:t>
+            </a:r>
+            <a:r>
+              <a:rPr lang="en-US" altLang="ko-KR" baseline="0" dirty="0" smtClean="0"/>
+              <a:t>.</a:t>
+            </a:r>
+            <a:endParaRPr lang="en-US" altLang="ko-KR" dirty="0" smtClean="0"/>
+          </a:p>
+          <a:p>
+            <a:endParaRPr lang="en-US" altLang="ko-KR" dirty="0" smtClean="0"/>
+          </a:p>
+          <a:p>
+            <a:r>
+              <a:rPr lang="en-US" altLang="ko-KR" dirty="0" smtClean="0"/>
               <a:t>grid</a:t>
             </a:r>
             <a:r>
+              <a:rPr lang="ko-KR" altLang="en-US" dirty="0" smtClean="0"/>
+              <a:t> </a:t>
+            </a:r>
+            <a:r>
               <a:rPr lang="ko-KR" altLang="en-US" dirty="0"/>
-              <a:t> 는 지금 배우기에 너무 어지러우니 나중에 다시 만나요</a:t>
-            </a:r>
-            <a:r>
-              <a:rPr lang="en-US" altLang="ko-KR" dirty="0"/>
+              <a:t>는 지금 배우기에 너무 어지러우니 나중에 다시 만나요</a:t>
+            </a:r>
+            <a:r>
+              <a:rPr lang="en-US" altLang="ko-KR" dirty="0" smtClean="0"/>
               <a:t>!!</a:t>
+            </a:r>
+          </a:p>
+          <a:p>
+            <a:endParaRPr lang="en-US" altLang="ko-KR" dirty="0" smtClean="0"/>
+          </a:p>
+          <a:p>
+            <a:r>
+              <a:rPr lang="ko-KR" altLang="en-US" dirty="0" smtClean="0"/>
+              <a:t>코드 치러 </a:t>
+            </a:r>
+            <a:r>
+              <a:rPr lang="en-US" altLang="ko-KR" dirty="0" err="1" smtClean="0"/>
+              <a:t>rr</a:t>
+            </a:r>
+            <a:endParaRPr lang="en-US" altLang="ko-KR" dirty="0" smtClean="0"/>
+          </a:p>
+          <a:p>
+            <a:endParaRPr lang="en-US" altLang="ko-KR" dirty="0" smtClean="0"/>
+          </a:p>
+          <a:p>
+            <a:r>
+              <a:rPr lang="en-US" altLang="ko-KR" dirty="0" smtClean="0"/>
+              <a:t>Html 10</a:t>
             </a:r>
             <a:endParaRPr lang="ko-KR" altLang="en-US" dirty="0"/>
           </a:p>
@@ -1649,65 +1724,7 @@
           <a:bodyPr/>
           <a:lstStyle/>
           <a:p>
-            <a:r>
-              <a:rPr lang="ko-KR" altLang="en-US" dirty="0"/>
-              <a:t>요거는 수업 끝나고 만들어 볼 것</a:t>
-            </a:r>
-            <a:r>
-              <a:rPr lang="en-US" altLang="ko-KR" dirty="0"/>
-              <a:t>. </a:t>
-            </a:r>
-          </a:p>
-          <a:p>
-            <a:r>
-              <a:rPr lang="ko-KR" altLang="en-US" dirty="0"/>
-              <a:t>윤곽이 잡혀있는 </a:t>
-            </a:r>
-            <a:r>
-              <a:rPr lang="en-US" altLang="ko-KR" dirty="0"/>
-              <a:t>html</a:t>
-            </a:r>
-            <a:r>
-              <a:rPr lang="ko-KR" altLang="en-US" dirty="0"/>
-              <a:t>파일과  </a:t>
-            </a:r>
-            <a:r>
-              <a:rPr lang="en-US" altLang="ko-KR" dirty="0" err="1"/>
-              <a:t>css</a:t>
-            </a:r>
-            <a:r>
-              <a:rPr lang="ko-KR" altLang="en-US" dirty="0"/>
-              <a:t>파일을 드릴 것이니 미리 풀지 말라</a:t>
-            </a:r>
-            <a:r>
-              <a:rPr lang="en-US" altLang="ko-KR" dirty="0"/>
-              <a:t>~~~~~~</a:t>
-            </a:r>
-          </a:p>
-          <a:p>
-            <a:endParaRPr lang="en-US" altLang="ko-KR" dirty="0"/>
-          </a:p>
-          <a:p>
-            <a:r>
-              <a:rPr lang="ko-KR" altLang="en-US" dirty="0"/>
-              <a:t>수업준비</a:t>
-            </a:r>
-            <a:r>
-              <a:rPr lang="en-US" altLang="ko-KR" dirty="0"/>
-              <a:t>/230705/practice/header.html </a:t>
-            </a:r>
-            <a:r>
-              <a:rPr lang="ko-KR" altLang="en-US" dirty="0"/>
-              <a:t>과 </a:t>
-            </a:r>
-            <a:r>
-              <a:rPr lang="en-US" altLang="ko-KR" dirty="0"/>
-              <a:t>header.css </a:t>
-            </a:r>
-            <a:r>
-              <a:rPr lang="ko-KR" altLang="en-US" dirty="0"/>
-              <a:t>전달하기</a:t>
-            </a:r>
+            <a:endParaRPr lang="ko-KR" altLang="en-US" dirty="0"/>
           </a:p>
         </p:txBody>
       </p:sp>
@@ -1718,15 +1735,15 @@
             <a:spLocks noGrp="1"/>
           </p:cNvSpPr>
           <p:nvPr>
-            <p:ph type="sldNum" sz="quarter" idx="10"/>
-          </p:nvPr>
-        </p:nvSpPr>
-        <p:spPr/>
-        <p:txBody>
-          <a:bodyPr/>
-          <a:lstStyle/>
-          <a:p>
-            <a:fld id="{A55743F5-9E7E-4395-8C78-F5A3CC3D6840}" type="slidenum">
+            <p:ph type="sldNum" sz="quarter" idx="5"/>
+          </p:nvPr>
+        </p:nvSpPr>
+        <p:spPr/>
+        <p:txBody>
+          <a:bodyPr/>
+          <a:lstStyle/>
+          <a:p>
+            <a:fld id="{C09E5BFC-1559-42F1-8940-AB342D56BF02}" type="slidenum">
               <a:rPr lang="ko-KR" altLang="en-US" smtClean="0"/>
               <a:t>19</a:t>
             </a:fld>
@@ -1737,7 +1754,7 @@
     </p:spTree>
     <p:extLst>
       <p:ext uri="{BB962C8B-B14F-4D97-AF65-F5344CB8AC3E}">
-        <p14:creationId xmlns:p14="http://schemas.microsoft.com/office/powerpoint/2010/main" val="864912781"/>
+        <p14:creationId xmlns:p14="http://schemas.microsoft.com/office/powerpoint/2010/main" val="164527025"/>
       </p:ext>
     </p:extLst>
   </p:cSld>
@@ -1791,6 +1808,25 @@
           <a:bodyPr/>
           <a:lstStyle/>
           <a:p>
+            <a:r>
+              <a:rPr lang="ko-KR" altLang="en-US" dirty="0" smtClean="0"/>
+              <a:t>코드</a:t>
+            </a:r>
+            <a:r>
+              <a:rPr lang="ko-KR" altLang="en-US" baseline="0" dirty="0" smtClean="0"/>
+              <a:t> 치러 </a:t>
+            </a:r>
+            <a:r>
+              <a:rPr lang="ko-KR" altLang="en-US" baseline="0" dirty="0" err="1" smtClean="0"/>
+              <a:t>ㄱㄱ</a:t>
+            </a:r>
+            <a:endParaRPr lang="en-US" altLang="ko-KR" baseline="0" dirty="0" smtClean="0"/>
+          </a:p>
+          <a:p>
+            <a:r>
+              <a:rPr lang="en-US" altLang="ko-KR" baseline="0" dirty="0" smtClean="0"/>
+              <a:t>Html11 </a:t>
+            </a:r>
             <a:endParaRPr lang="ko-KR" altLang="en-US" dirty="0"/>
           </a:p>
         </p:txBody>
@@ -1802,17 +1838,17 @@
             <a:spLocks noGrp="1"/>
           </p:cNvSpPr>
           <p:nvPr>
-            <p:ph type="sldNum" sz="quarter" idx="5"/>
-          </p:nvPr>
-        </p:nvSpPr>
-        <p:spPr/>
-        <p:txBody>
-          <a:bodyPr/>
-          <a:lstStyle/>
-          <a:p>
-            <a:fld id="{C09E5BFC-1559-42F1-8940-AB342D56BF02}" type="slidenum">
+            <p:ph type="sldNum" sz="quarter" idx="10"/>
+          </p:nvPr>
+        </p:nvSpPr>
+        <p:spPr/>
+        <p:txBody>
+          <a:bodyPr/>
+          <a:lstStyle/>
+          <a:p>
+            <a:fld id="{FA70C596-B40F-4F83-8FE4-5CF99F6F6723}" type="slidenum">
               <a:rPr lang="ko-KR" altLang="en-US" smtClean="0"/>
-              <a:t>21</a:t>
+              <a:t>20</a:t>
             </a:fld>
             <a:endParaRPr lang="ko-KR" altLang="en-US"/>
           </a:p>
@@ -1821,7 +1857,7 @@
     </p:spTree>
     <p:extLst>
       <p:ext uri="{BB962C8B-B14F-4D97-AF65-F5344CB8AC3E}">
-        <p14:creationId xmlns:p14="http://schemas.microsoft.com/office/powerpoint/2010/main" val="1031924123"/>
+        <p14:creationId xmlns:p14="http://schemas.microsoft.com/office/powerpoint/2010/main" val="1127114302"/>
       </p:ext>
     </p:extLst>
   </p:cSld>
@@ -1877,126 +1913,72 @@
           <a:p>
             <a:r>
               <a:rPr lang="ko-KR" altLang="en-US" dirty="0"/>
-              <a:t>우리가 만들어주는 이름</a:t>
+              <a:t>요거는 수업 끝나고 만들어 볼 것</a:t>
+            </a:r>
+            <a:r>
+              <a:rPr lang="en-US" altLang="ko-KR" dirty="0"/>
+              <a:t>. </a:t>
+            </a:r>
+            <a:r>
+              <a:rPr lang="ko-KR" altLang="en-US" dirty="0" smtClean="0"/>
+              <a:t>과제</a:t>
+            </a:r>
+            <a:r>
+              <a:rPr lang="en-US" altLang="ko-KR" dirty="0" smtClean="0"/>
+              <a:t>!</a:t>
             </a:r>
             <a:endParaRPr lang="en-US" altLang="ko-KR" dirty="0"/>
           </a:p>
           <a:p>
             <a:r>
               <a:rPr lang="ko-KR" altLang="en-US" dirty="0"/>
-              <a:t>지속시간 </a:t>
+              <a:t>윤곽이 잡혀있는 </a:t>
             </a:r>
             <a:r>
               <a:rPr lang="en-US" altLang="ko-KR" dirty="0"/>
-              <a:t>~s</a:t>
-            </a:r>
-            <a:r>
-              <a:rPr lang="en-US" altLang="ko-KR" baseline="0" dirty="0"/>
-              <a:t> </a:t>
-            </a:r>
-            <a:r>
-              <a:rPr lang="ko-KR" altLang="en-US" baseline="0" dirty="0"/>
-              <a:t>의 몇 초 형태</a:t>
-            </a:r>
-            <a:endParaRPr lang="en-US" altLang="ko-KR" baseline="0" dirty="0"/>
-          </a:p>
-          <a:p>
-            <a:r>
-              <a:rPr lang="ko-KR" altLang="en-US" baseline="0" dirty="0"/>
-              <a:t>진행 형태 </a:t>
-            </a:r>
-            <a:r>
-              <a:rPr lang="en-US" altLang="ko-KR" baseline="0" dirty="0"/>
-              <a:t>: </a:t>
-            </a:r>
-            <a:r>
-              <a:rPr lang="ko-KR" altLang="en-US" baseline="0" dirty="0"/>
-              <a:t>시간 함수</a:t>
-            </a:r>
-            <a:r>
-              <a:rPr lang="en-US" altLang="ko-KR" baseline="0" dirty="0"/>
-              <a:t>, transition </a:t>
-            </a:r>
-            <a:r>
-              <a:rPr lang="ko-KR" altLang="en-US" baseline="0" dirty="0"/>
-              <a:t>의 </a:t>
-            </a:r>
-            <a:r>
-              <a:rPr lang="en-US" altLang="ko-KR" baseline="0" dirty="0"/>
-              <a:t>timing-function</a:t>
-            </a:r>
-            <a:r>
-              <a:rPr lang="ko-KR" altLang="en-US" baseline="0" dirty="0"/>
-              <a:t>과 동일</a:t>
-            </a:r>
-            <a:r>
-              <a:rPr lang="en-US" altLang="ko-KR" baseline="0" dirty="0"/>
-              <a:t>. </a:t>
-            </a:r>
-            <a:r>
-              <a:rPr lang="en-US" altLang="ko-KR" baseline="0" dirty="0" err="1"/>
-              <a:t>animatio</a:t>
-            </a:r>
-            <a:r>
-              <a:rPr lang="ko-KR" altLang="en-US" baseline="0" dirty="0"/>
-              <a:t>의 길이는 </a:t>
-            </a:r>
-            <a:r>
-              <a:rPr lang="en-US" altLang="ko-KR" baseline="0" dirty="0" err="1"/>
-              <a:t>transitio</a:t>
-            </a:r>
-            <a:r>
-              <a:rPr lang="ko-KR" altLang="en-US" baseline="0" dirty="0"/>
-              <a:t>과 다르게 지속 시간이 긴 경우가 많기 때문에 움직임이 </a:t>
-            </a:r>
-            <a:r>
-              <a:rPr lang="en-US" altLang="ko-KR" baseline="0" dirty="0"/>
-              <a:t>timing </a:t>
-            </a:r>
-            <a:r>
-              <a:rPr lang="en-US" altLang="ko-KR" baseline="0" dirty="0" err="1"/>
-              <a:t>functio</a:t>
-            </a:r>
-            <a:r>
-              <a:rPr lang="ko-KR" altLang="en-US" baseline="0" dirty="0"/>
-              <a:t>에 따라서 바뀐다</a:t>
-            </a:r>
-            <a:r>
-              <a:rPr lang="en-US" altLang="ko-KR" baseline="0" dirty="0"/>
-              <a:t>. </a:t>
-            </a:r>
-            <a:r>
-              <a:rPr lang="en-US" altLang="ko-KR" baseline="0" dirty="0" err="1"/>
-              <a:t>animaitio</a:t>
-            </a:r>
-            <a:r>
-              <a:rPr lang="ko-KR" altLang="en-US" baseline="0" dirty="0"/>
-              <a:t>에서의 </a:t>
-            </a:r>
-            <a:r>
-              <a:rPr lang="en-US" altLang="ko-KR" baseline="0" dirty="0"/>
-              <a:t>ease linear </a:t>
-            </a:r>
-            <a:r>
-              <a:rPr lang="ko-KR" altLang="en-US" baseline="0" dirty="0"/>
-              <a:t>등의 시간 함수는 꽤 중요한 역할을 함</a:t>
-            </a:r>
-            <a:endParaRPr lang="en-US" altLang="ko-KR" baseline="0" dirty="0"/>
-          </a:p>
-          <a:p>
-            <a:r>
-              <a:rPr lang="ko-KR" altLang="en-US" dirty="0" err="1"/>
-              <a:t>반복횟수</a:t>
+              <a:t>html</a:t>
             </a:r>
             <a:r>
               <a:rPr lang="ko-KR" altLang="en-US" dirty="0"/>
-              <a:t> </a:t>
+              <a:t>파일과  </a:t>
+            </a:r>
+            <a:r>
+              <a:rPr lang="en-US" altLang="ko-KR" dirty="0" err="1"/>
+              <a:t>css</a:t>
+            </a:r>
+            <a:r>
+              <a:rPr lang="ko-KR" altLang="en-US" dirty="0"/>
+              <a:t>파일을 드릴 것이니 미리 풀지 말라</a:t>
             </a:r>
             <a:r>
               <a:rPr lang="en-US" altLang="ko-KR" dirty="0"/>
-              <a:t>(iteration-count)</a:t>
-            </a:r>
-            <a:endParaRPr lang="ko-KR" altLang="en-US" dirty="0"/>
+              <a:t>~~~~~~</a:t>
+            </a:r>
+          </a:p>
+          <a:p>
+            <a:endParaRPr lang="en-US" altLang="ko-KR" dirty="0"/>
+          </a:p>
+          <a:p>
+            <a:r>
+              <a:rPr lang="ko-KR" altLang="en-US" dirty="0"/>
+              <a:t>수업준비</a:t>
+            </a:r>
+            <a:r>
+              <a:rPr lang="en-US" altLang="ko-KR" dirty="0"/>
+              <a:t>/230705/practice/header.html </a:t>
+            </a:r>
+            <a:r>
+              <a:rPr lang="ko-KR" altLang="en-US" dirty="0"/>
+              <a:t>과 </a:t>
+            </a:r>
+            <a:r>
+              <a:rPr lang="en-US" altLang="ko-KR" dirty="0"/>
+              <a:t>header.css </a:t>
+            </a:r>
+            <a:r>
+              <a:rPr lang="ko-KR" altLang="en-US" dirty="0"/>
+              <a:t>전달하기</a:t>
+            </a:r>
           </a:p>
         </p:txBody>
       </p:sp>
@@ -2015,19 +1997,18 @@
           <a:bodyPr/>
           <a:lstStyle/>
           <a:p>
-            <a:fld id="{B4FAD15D-3FC6-4EBB-8A1D-F20C53EB7780}" type="slidenum">
+            <a:fld id="{A55743F5-9E7E-4395-8C78-F5A3CC3D6840}" type="slidenum">
               <a:rPr lang="ko-KR" altLang="en-US" smtClean="0"/>
-              <a:pPr/>
-              <a:t>22</a:t>
+              <a:t>21</a:t>
             </a:fld>
-            <a:endParaRPr lang="ko-KR" altLang="en-US" dirty="0"/>
+            <a:endParaRPr lang="ko-KR" altLang="en-US"/>
           </a:p>
         </p:txBody>
       </p:sp>
     </p:spTree>
     <p:extLst>
       <p:ext uri="{BB962C8B-B14F-4D97-AF65-F5344CB8AC3E}">
-        <p14:creationId xmlns:p14="http://schemas.microsoft.com/office/powerpoint/2010/main" val="2638017959"/>
+        <p14:creationId xmlns:p14="http://schemas.microsoft.com/office/powerpoint/2010/main" val="864912781"/>
       </p:ext>
     </p:extLst>
   </p:cSld>
@@ -2082,59 +2063,37 @@
           <a:lstStyle/>
           <a:p>
             <a:r>
-              <a:rPr lang="ko-KR" altLang="en-US" dirty="0" err="1"/>
-              <a:t>파란글씨</a:t>
-            </a:r>
-            <a:r>
-              <a:rPr lang="ko-KR" altLang="en-US" dirty="0"/>
-              <a:t> 필수 속성 </a:t>
-            </a:r>
-            <a:endParaRPr lang="en-US" altLang="ko-KR" dirty="0"/>
-          </a:p>
-          <a:p>
-            <a:r>
-              <a:rPr lang="ko-KR" altLang="en-US" dirty="0"/>
-              <a:t>까만 글씨 생략 가능 </a:t>
-            </a:r>
-            <a:endParaRPr lang="en-US" altLang="ko-KR" dirty="0"/>
-          </a:p>
-          <a:p>
-            <a:r>
-              <a:rPr lang="en-US" altLang="ko-KR" dirty="0"/>
-              <a:t>Timing-</a:t>
-            </a:r>
-            <a:r>
-              <a:rPr lang="en-US" altLang="ko-KR" dirty="0" err="1"/>
-              <a:t>funciton</a:t>
-            </a:r>
-            <a:r>
-              <a:rPr lang="ko-KR" altLang="en-US" dirty="0"/>
-              <a:t>은 보통 써주지만 </a:t>
-            </a:r>
-            <a:r>
-              <a:rPr lang="en-US" altLang="ko-KR" dirty="0"/>
-              <a:t>delay</a:t>
-            </a:r>
-            <a:r>
-              <a:rPr lang="ko-KR" altLang="en-US" dirty="0"/>
-              <a:t>랑 </a:t>
-            </a:r>
-            <a:r>
-              <a:rPr lang="en-US" altLang="ko-KR" dirty="0"/>
-              <a:t>direction</a:t>
-            </a:r>
-            <a:r>
-              <a:rPr lang="ko-KR" altLang="en-US" dirty="0"/>
-              <a:t>은 안써주는 경우가 </a:t>
-            </a:r>
-            <a:r>
-              <a:rPr lang="ko-KR" altLang="en-US" dirty="0" err="1"/>
-              <a:t>만타</a:t>
-            </a:r>
-            <a:r>
-              <a:rPr lang="en-US" altLang="ko-KR" dirty="0"/>
-              <a:t>!</a:t>
-            </a:r>
+              <a:rPr lang="en-US" altLang="ko-KR" dirty="0" smtClean="0"/>
+              <a:t>Animation </a:t>
+            </a:r>
+            <a:r>
+              <a:rPr lang="ko-KR" altLang="en-US" dirty="0" smtClean="0"/>
+              <a:t>속성은 요소에 애니메이션 효과를 적용할 수 있게 함</a:t>
+            </a:r>
+            <a:r>
+              <a:rPr lang="en-US" altLang="ko-KR" dirty="0" smtClean="0"/>
+              <a:t>.</a:t>
+            </a:r>
+          </a:p>
+          <a:p>
+            <a:r>
+              <a:rPr lang="ko-KR" altLang="en-US" dirty="0" smtClean="0"/>
+              <a:t>요소의 스타일을 점진적으로 변화시켜주는 기능으로 다양한 시각적 효과를 </a:t>
+            </a:r>
+            <a:r>
+              <a:rPr lang="ko-KR" altLang="en-US" dirty="0" err="1" smtClean="0"/>
+              <a:t>구현할수</a:t>
+            </a:r>
+            <a:r>
+              <a:rPr lang="ko-KR" altLang="en-US" dirty="0" smtClean="0"/>
+              <a:t> 있음</a:t>
+            </a:r>
+            <a:r>
+              <a:rPr lang="en-US" altLang="ko-KR" dirty="0" smtClean="0"/>
+              <a:t>.</a:t>
+            </a:r>
+          </a:p>
+          <a:p>
             <a:endParaRPr lang="ko-KR" altLang="en-US" dirty="0"/>
           </a:p>
         </p:txBody>
@@ -2146,17 +2105,17 @@
             <a:spLocks noGrp="1"/>
           </p:cNvSpPr>
           <p:nvPr>
-            <p:ph type="sldNum" sz="quarter" idx="10"/>
-          </p:nvPr>
-        </p:nvSpPr>
-        <p:spPr/>
-        <p:txBody>
-          <a:bodyPr/>
-          <a:lstStyle/>
-          <a:p>
-            <a:fld id="{B4FAD15D-3FC6-4EBB-8A1D-F20C53EB7780}" type="slidenum">
+            <p:ph type="sldNum" sz="quarter" idx="5"/>
+          </p:nvPr>
+        </p:nvSpPr>
+        <p:spPr/>
+        <p:txBody>
+          <a:bodyPr/>
+          <a:lstStyle/>
+          <a:p>
+            <a:fld id="{C09E5BFC-1559-42F1-8940-AB342D56BF02}" type="slidenum">
               <a:rPr lang="ko-KR" altLang="en-US" smtClean="0"/>
-              <a:t>23</a:t>
+              <a:t>22</a:t>
             </a:fld>
             <a:endParaRPr lang="ko-KR" altLang="en-US"/>
           </a:p>
@@ -2165,7 +2124,7 @@
     </p:spTree>
     <p:extLst>
       <p:ext uri="{BB962C8B-B14F-4D97-AF65-F5344CB8AC3E}">
-        <p14:creationId xmlns:p14="http://schemas.microsoft.com/office/powerpoint/2010/main" val="2277054390"/>
+        <p14:creationId xmlns:p14="http://schemas.microsoft.com/office/powerpoint/2010/main" val="524032485"/>
       </p:ext>
     </p:extLst>
   </p:cSld>
@@ -2303,410 +2262,12 @@
           <a:bodyPr/>
           <a:lstStyle/>
           <a:p>
-            <a:pPr marL="0" marR="0" lvl="0" indent="0" algn="l" defTabSz="914400" rtl="0" eaLnBrk="1" fontAlgn="auto" latinLnBrk="1" hangingPunct="1">
-              <a:lnSpc>
-                <a:spcPct val="100000"/>
-              </a:lnSpc>
-              <a:spcBef>
-                <a:spcPts val="0"/>
-              </a:spcBef>
-              <a:spcAft>
-                <a:spcPts val="0"/>
-              </a:spcAft>
-              <a:buClrTx/>
-              <a:buSzTx/>
-              <a:buFontTx/>
-              <a:buNone/>
-              <a:tabLst/>
-              <a:defRPr/>
-            </a:pPr>
-            <a:r>
-              <a:rPr lang="en-US" altLang="ko-KR" dirty="0"/>
-              <a:t>kdt3rd-workspace/03_css/</a:t>
-            </a:r>
-            <a:r>
-              <a:rPr lang="en-US" altLang="ko-KR" b="1" dirty="0"/>
-              <a:t>index10.html </a:t>
-            </a:r>
-          </a:p>
-          <a:p>
-            <a:pPr marL="0" marR="0" lvl="0" indent="0" algn="l" defTabSz="914400" rtl="0" eaLnBrk="1" fontAlgn="auto" latinLnBrk="1" hangingPunct="1">
-              <a:lnSpc>
-                <a:spcPct val="100000"/>
-              </a:lnSpc>
-              <a:spcBef>
-                <a:spcPts val="0"/>
-              </a:spcBef>
-              <a:spcAft>
-                <a:spcPts val="0"/>
-              </a:spcAft>
-              <a:buClrTx/>
-              <a:buSzTx/>
-              <a:buFontTx/>
-              <a:buNone/>
-              <a:tabLst/>
-              <a:defRPr/>
-            </a:pPr>
-            <a:r>
-              <a:rPr lang="en-US" altLang="ko-KR" dirty="0"/>
-              <a:t>kdt3rd-workspace/03_css/</a:t>
-            </a:r>
-            <a:r>
-              <a:rPr lang="en-US" altLang="ko-KR" b="1" dirty="0"/>
-              <a:t>index10.css</a:t>
-            </a:r>
-          </a:p>
-          <a:p>
-            <a:pPr marL="0" marR="0" lvl="0" indent="0" algn="l" defTabSz="914400" rtl="0" eaLnBrk="1" fontAlgn="auto" latinLnBrk="1" hangingPunct="1">
-              <a:lnSpc>
-                <a:spcPct val="100000"/>
-              </a:lnSpc>
-              <a:spcBef>
-                <a:spcPts val="0"/>
-              </a:spcBef>
-              <a:spcAft>
-                <a:spcPts val="0"/>
-              </a:spcAft>
-              <a:buClrTx/>
-              <a:buSzTx/>
-              <a:buFontTx/>
-              <a:buNone/>
-              <a:tabLst/>
-              <a:defRPr/>
-            </a:pPr>
-            <a:endParaRPr lang="en-US" altLang="ko-KR" b="1" dirty="0"/>
-          </a:p>
-          <a:p>
-            <a:pPr marL="0" marR="0" lvl="0" indent="0" algn="l" defTabSz="914400" rtl="0" eaLnBrk="1" fontAlgn="auto" latinLnBrk="1" hangingPunct="1">
-              <a:lnSpc>
-                <a:spcPct val="100000"/>
-              </a:lnSpc>
-              <a:spcBef>
-                <a:spcPts val="0"/>
-              </a:spcBef>
-              <a:spcAft>
-                <a:spcPts val="0"/>
-              </a:spcAft>
-              <a:buClrTx/>
-              <a:buSzTx/>
-              <a:buFontTx/>
-              <a:buNone/>
-              <a:tabLst/>
-              <a:defRPr/>
-            </a:pPr>
-            <a:endParaRPr lang="en-US" altLang="ko-KR" b="1" dirty="0"/>
-          </a:p>
-          <a:p>
-            <a:pPr marL="0" marR="0" lvl="0" indent="0" algn="l" defTabSz="914400" rtl="0" eaLnBrk="1" fontAlgn="auto" latinLnBrk="1" hangingPunct="1">
-              <a:lnSpc>
-                <a:spcPct val="100000"/>
-              </a:lnSpc>
-              <a:spcBef>
-                <a:spcPts val="0"/>
-              </a:spcBef>
-              <a:spcAft>
-                <a:spcPts val="0"/>
-              </a:spcAft>
-              <a:buClrTx/>
-              <a:buSzTx/>
-              <a:buFontTx/>
-              <a:buNone/>
-              <a:tabLst/>
-              <a:defRPr/>
-            </a:pPr>
-            <a:r>
-              <a:rPr lang="en-US" altLang="ko-KR" b="1" dirty="0"/>
-              <a:t>=============================</a:t>
-            </a:r>
-          </a:p>
-          <a:p>
-            <a:pPr marL="0" marR="0" lvl="0" indent="0" algn="l" defTabSz="914400" rtl="0" eaLnBrk="1" fontAlgn="auto" latinLnBrk="1" hangingPunct="1">
-              <a:lnSpc>
-                <a:spcPct val="100000"/>
-              </a:lnSpc>
-              <a:spcBef>
-                <a:spcPts val="0"/>
-              </a:spcBef>
-              <a:spcAft>
-                <a:spcPts val="0"/>
-              </a:spcAft>
-              <a:buClrTx/>
-              <a:buSzTx/>
-              <a:buFontTx/>
-              <a:buNone/>
-              <a:tabLst/>
-              <a:defRPr/>
-            </a:pPr>
-            <a:r>
-              <a:rPr lang="ko-KR" altLang="en-US" b="1" dirty="0"/>
-              <a:t>다음 페이지 </a:t>
-            </a:r>
-            <a:r>
-              <a:rPr lang="en-US" altLang="ko-KR" b="1" dirty="0"/>
-              <a:t>&gt; </a:t>
-            </a:r>
-            <a:r>
-              <a:rPr lang="ko-KR" altLang="en-US" b="1" dirty="0"/>
-              <a:t>실습 </a:t>
-            </a:r>
-            <a:r>
-              <a:rPr lang="en-US" altLang="ko-KR" b="1" dirty="0"/>
-              <a:t>10</a:t>
-            </a:r>
-          </a:p>
-          <a:p>
-            <a:pPr marL="0" marR="0" lvl="0" indent="0" algn="l" defTabSz="914400" rtl="0" eaLnBrk="1" fontAlgn="auto" latinLnBrk="1" hangingPunct="1">
-              <a:lnSpc>
-                <a:spcPct val="100000"/>
-              </a:lnSpc>
-              <a:spcBef>
-                <a:spcPts val="0"/>
-              </a:spcBef>
-              <a:spcAft>
-                <a:spcPts val="0"/>
-              </a:spcAft>
-              <a:buClrTx/>
-              <a:buSzTx/>
-              <a:buFontTx/>
-              <a:buNone/>
-              <a:tabLst/>
-              <a:defRPr/>
-            </a:pPr>
-            <a:r>
-              <a:rPr lang="en-US" altLang="ko-KR" dirty="0"/>
-              <a:t>kdt3rd-workspace/03_css/</a:t>
-            </a:r>
-            <a:r>
-              <a:rPr lang="en-US" altLang="ko-KR" b="1" dirty="0"/>
-              <a:t>practice10.html </a:t>
-            </a:r>
-          </a:p>
-          <a:p>
-            <a:pPr marL="0" marR="0" lvl="0" indent="0" algn="l" defTabSz="914400" rtl="0" eaLnBrk="1" fontAlgn="auto" latinLnBrk="1" hangingPunct="1">
-              <a:lnSpc>
-                <a:spcPct val="100000"/>
-              </a:lnSpc>
-              <a:spcBef>
-                <a:spcPts val="0"/>
-              </a:spcBef>
-              <a:spcAft>
-                <a:spcPts val="0"/>
-              </a:spcAft>
-              <a:buClrTx/>
-              <a:buSzTx/>
-              <a:buFontTx/>
-              <a:buNone/>
-              <a:tabLst/>
-              <a:defRPr/>
-            </a:pPr>
-            <a:r>
-              <a:rPr lang="en-US" altLang="ko-KR" dirty="0"/>
-              <a:t>kdt3rd-workspace/03_css/</a:t>
-            </a:r>
-            <a:r>
-              <a:rPr lang="en-US" altLang="ko-KR" b="1" dirty="0"/>
-              <a:t>practice10.css</a:t>
-            </a:r>
-          </a:p>
-          <a:p>
-            <a:pPr marL="0" marR="0" lvl="0" indent="0" algn="l" defTabSz="914400" rtl="0" eaLnBrk="1" fontAlgn="auto" latinLnBrk="1" hangingPunct="1">
-              <a:lnSpc>
-                <a:spcPct val="100000"/>
-              </a:lnSpc>
-              <a:spcBef>
-                <a:spcPts val="0"/>
-              </a:spcBef>
-              <a:spcAft>
-                <a:spcPts val="0"/>
-              </a:spcAft>
-              <a:buClrTx/>
-              <a:buSzTx/>
-              <a:buFontTx/>
-              <a:buNone/>
-              <a:tabLst/>
-              <a:defRPr/>
-            </a:pPr>
-            <a:endParaRPr lang="en-US" altLang="ko-KR" b="1" dirty="0"/>
-          </a:p>
-          <a:p>
-            <a:pPr marL="0" marR="0" lvl="0" indent="0" algn="l" defTabSz="914400" rtl="0" eaLnBrk="1" fontAlgn="auto" latinLnBrk="1" hangingPunct="1">
-              <a:lnSpc>
-                <a:spcPct val="100000"/>
-              </a:lnSpc>
-              <a:spcBef>
-                <a:spcPts val="0"/>
-              </a:spcBef>
-              <a:spcAft>
-                <a:spcPts val="0"/>
-              </a:spcAft>
-              <a:buClrTx/>
-              <a:buSzTx/>
-              <a:buFontTx/>
-              <a:buNone/>
-              <a:tabLst/>
-              <a:defRPr/>
-            </a:pPr>
-            <a:r>
-              <a:rPr lang="en-US" altLang="ko-KR" b="1" dirty="0"/>
-              <a:t>=============================</a:t>
-            </a:r>
-          </a:p>
-          <a:p>
-            <a:pPr marL="0" marR="0" lvl="0" indent="0" algn="l" defTabSz="914400" rtl="0" eaLnBrk="1" fontAlgn="auto" latinLnBrk="1" hangingPunct="1">
-              <a:lnSpc>
-                <a:spcPct val="100000"/>
-              </a:lnSpc>
-              <a:spcBef>
-                <a:spcPts val="0"/>
-              </a:spcBef>
-              <a:spcAft>
-                <a:spcPts val="0"/>
-              </a:spcAft>
-              <a:buClrTx/>
-              <a:buSzTx/>
-              <a:buFontTx/>
-              <a:buNone/>
-              <a:tabLst/>
-              <a:defRPr/>
-            </a:pPr>
-            <a:r>
-              <a:rPr lang="ko-KR" altLang="en-US" b="1" dirty="0"/>
-              <a:t>다음 페이지 </a:t>
-            </a:r>
-            <a:r>
-              <a:rPr lang="en-US" altLang="ko-KR" b="1" dirty="0"/>
-              <a:t>&gt; </a:t>
-            </a:r>
-            <a:r>
-              <a:rPr lang="ko-KR" altLang="en-US" b="1" dirty="0"/>
-              <a:t>실습 </a:t>
-            </a:r>
-            <a:r>
-              <a:rPr lang="en-US" altLang="ko-KR" b="1" dirty="0"/>
-              <a:t>11</a:t>
-            </a:r>
-          </a:p>
-          <a:p>
-            <a:pPr marL="0" marR="0" lvl="0" indent="0" algn="l" defTabSz="914400" rtl="0" eaLnBrk="1" fontAlgn="auto" latinLnBrk="1" hangingPunct="1">
-              <a:lnSpc>
-                <a:spcPct val="100000"/>
-              </a:lnSpc>
-              <a:spcBef>
-                <a:spcPts val="0"/>
-              </a:spcBef>
-              <a:spcAft>
-                <a:spcPts val="0"/>
-              </a:spcAft>
-              <a:buClrTx/>
-              <a:buSzTx/>
-              <a:buFontTx/>
-              <a:buNone/>
-              <a:tabLst/>
-              <a:defRPr/>
-            </a:pPr>
-            <a:r>
-              <a:rPr lang="en-US" altLang="ko-KR" dirty="0"/>
-              <a:t>kdt3rd-workspace/03_css/</a:t>
-            </a:r>
-            <a:r>
-              <a:rPr lang="en-US" altLang="ko-KR" b="1" dirty="0"/>
-              <a:t>practice11.html </a:t>
-            </a:r>
-          </a:p>
-          <a:p>
-            <a:pPr marL="0" marR="0" lvl="0" indent="0" algn="l" defTabSz="914400" rtl="0" eaLnBrk="1" fontAlgn="auto" latinLnBrk="1" hangingPunct="1">
-              <a:lnSpc>
-                <a:spcPct val="100000"/>
-              </a:lnSpc>
-              <a:spcBef>
-                <a:spcPts val="0"/>
-              </a:spcBef>
-              <a:spcAft>
-                <a:spcPts val="0"/>
-              </a:spcAft>
-              <a:buClrTx/>
-              <a:buSzTx/>
-              <a:buFontTx/>
-              <a:buNone/>
-              <a:tabLst/>
-              <a:defRPr/>
-            </a:pPr>
-            <a:r>
-              <a:rPr lang="en-US" altLang="ko-KR" dirty="0"/>
-              <a:t>kdt3rd-workspace/03_css</a:t>
-            </a:r>
-            <a:r>
-              <a:rPr lang="en-US" altLang="ko-KR"/>
-              <a:t>/</a:t>
-            </a:r>
-            <a:r>
-              <a:rPr lang="en-US" altLang="ko-KR" b="1"/>
-              <a:t>practice11.</a:t>
-            </a:r>
-            <a:r>
-              <a:rPr lang="en-US" altLang="ko-KR" b="1" dirty="0"/>
-              <a:t>css</a:t>
-            </a:r>
-            <a:endParaRPr lang="en-US" altLang="ko-KR" dirty="0"/>
-          </a:p>
-          <a:p>
-            <a:pPr marL="0" marR="0" lvl="0" indent="0" algn="l" defTabSz="914400" rtl="0" eaLnBrk="1" fontAlgn="auto" latinLnBrk="1" hangingPunct="1">
-              <a:lnSpc>
-                <a:spcPct val="100000"/>
-              </a:lnSpc>
-              <a:spcBef>
-                <a:spcPts val="0"/>
-              </a:spcBef>
-              <a:spcAft>
-                <a:spcPts val="0"/>
-              </a:spcAft>
-              <a:buClrTx/>
-              <a:buSzTx/>
-              <a:buFontTx/>
-              <a:buNone/>
-              <a:tabLst/>
-              <a:defRPr/>
-            </a:pPr>
-            <a:endParaRPr lang="en-US" altLang="ko-KR" dirty="0"/>
-          </a:p>
-          <a:p>
+            <a:r>
+              <a:rPr lang="ko-KR" altLang="en-US" dirty="0" smtClean="0"/>
+              <a:t>구성 모양</a:t>
+            </a:r>
             <a:endParaRPr lang="ko-KR" altLang="en-US" dirty="0"/>
           </a:p>
-          <a:p>
-            <a:endParaRPr lang="ko-KR" altLang="en-US" dirty="0"/>
-          </a:p>
-          <a:p>
-            <a:pPr marL="0" marR="0" lvl="0" indent="0" algn="l" defTabSz="914400" rtl="0" eaLnBrk="1" fontAlgn="auto" latinLnBrk="1" hangingPunct="1">
-              <a:lnSpc>
-                <a:spcPct val="100000"/>
-              </a:lnSpc>
-              <a:spcBef>
-                <a:spcPts val="0"/>
-              </a:spcBef>
-              <a:spcAft>
-                <a:spcPts val="0"/>
-              </a:spcAft>
-              <a:buClrTx/>
-              <a:buSzTx/>
-              <a:buFontTx/>
-              <a:buNone/>
-              <a:tabLst/>
-              <a:defRPr/>
-            </a:pPr>
-            <a:endParaRPr lang="en-US" altLang="ko-KR" dirty="0"/>
-          </a:p>
-          <a:p>
-            <a:endParaRPr lang="ko-KR" altLang="en-US" dirty="0"/>
-          </a:p>
-          <a:p>
-            <a:endParaRPr lang="ko-KR" altLang="en-US" dirty="0"/>
-          </a:p>
-          <a:p>
-            <a:endParaRPr lang="ko-KR" altLang="en-US" dirty="0"/>
-          </a:p>
-          <a:p>
-            <a:endParaRPr lang="ko-KR" altLang="en-US" dirty="0"/>
-          </a:p>
         </p:txBody>
       </p:sp>
       <p:sp>
@@ -2716,17 +2277,17 @@
             <a:spLocks noGrp="1"/>
           </p:cNvSpPr>
           <p:nvPr>
-            <p:ph type="sldNum" sz="quarter" idx="5"/>
-          </p:nvPr>
-        </p:nvSpPr>
-        <p:spPr/>
-        <p:txBody>
-          <a:bodyPr/>
-          <a:lstStyle/>
-          <a:p>
-            <a:fld id="{C09E5BFC-1559-42F1-8940-AB342D56BF02}" type="slidenum">
+            <p:ph type="sldNum" sz="quarter" idx="10"/>
+          </p:nvPr>
+        </p:nvSpPr>
+        <p:spPr/>
+        <p:txBody>
+          <a:bodyPr/>
+          <a:lstStyle/>
+          <a:p>
+            <a:fld id="{FA70C596-B40F-4F83-8FE4-5CF99F6F6723}" type="slidenum">
               <a:rPr lang="ko-KR" altLang="en-US" smtClean="0"/>
-              <a:t>24</a:t>
+              <a:t>23</a:t>
             </a:fld>
             <a:endParaRPr lang="ko-KR" altLang="en-US"/>
           </a:p>
@@ -2735,7 +2296,7 @@
     </p:spTree>
     <p:extLst>
       <p:ext uri="{BB962C8B-B14F-4D97-AF65-F5344CB8AC3E}">
-        <p14:creationId xmlns:p14="http://schemas.microsoft.com/office/powerpoint/2010/main" val="3704610732"/>
+        <p14:creationId xmlns:p14="http://schemas.microsoft.com/office/powerpoint/2010/main" val="3822268058"/>
       </p:ext>
     </p:extLst>
   </p:cSld>
@@ -2789,6 +2350,584 @@
           <a:bodyPr/>
           <a:lstStyle/>
           <a:p>
+            <a:r>
+              <a:rPr lang="en-US" altLang="ko-KR" dirty="0" err="1" smtClean="0"/>
+              <a:t>Keyframes</a:t>
+            </a:r>
+            <a:r>
+              <a:rPr lang="en-US" altLang="ko-KR" baseline="0" dirty="0" smtClean="0"/>
+              <a:t> </a:t>
+            </a:r>
+            <a:r>
+              <a:rPr lang="ko-KR" altLang="en-US" baseline="0" dirty="0" smtClean="0"/>
+              <a:t>규칙은 </a:t>
+            </a:r>
+            <a:r>
+              <a:rPr lang="en-US" altLang="ko-KR" baseline="0" dirty="0" smtClean="0"/>
+              <a:t>CSS</a:t>
+            </a:r>
+            <a:r>
+              <a:rPr lang="ko-KR" altLang="en-US" baseline="0" dirty="0" smtClean="0"/>
+              <a:t>에서 애니메이션의 특정 지점에서 애니메이션 효과를 개발자가 직접 지정하는 기능</a:t>
+            </a:r>
+            <a:endParaRPr lang="en-US" altLang="ko-KR" baseline="0" dirty="0" smtClean="0"/>
+          </a:p>
+          <a:p>
+            <a:endParaRPr lang="ko-KR" altLang="en-US" dirty="0"/>
+          </a:p>
+        </p:txBody>
+      </p:sp>
+      <p:sp>
+        <p:nvSpPr>
+          <p:cNvPr id="4" name="슬라이드 번호 개체 틀 3"/>
+          <p:cNvSpPr>
+            <a:spLocks noGrp="1"/>
+          </p:cNvSpPr>
+          <p:nvPr>
+            <p:ph type="sldNum" sz="quarter" idx="5"/>
+          </p:nvPr>
+        </p:nvSpPr>
+        <p:spPr/>
+        <p:txBody>
+          <a:bodyPr/>
+          <a:lstStyle/>
+          <a:p>
+            <a:fld id="{C09E5BFC-1559-42F1-8940-AB342D56BF02}" type="slidenum">
+              <a:rPr lang="ko-KR" altLang="en-US" smtClean="0"/>
+              <a:t>24</a:t>
+            </a:fld>
+            <a:endParaRPr lang="ko-KR" altLang="en-US"/>
+          </a:p>
+        </p:txBody>
+      </p:sp>
+    </p:spTree>
+    <p:extLst>
+      <p:ext uri="{BB962C8B-B14F-4D97-AF65-F5344CB8AC3E}">
+        <p14:creationId xmlns:p14="http://schemas.microsoft.com/office/powerpoint/2010/main" val="1031924123"/>
+      </p:ext>
+    </p:extLst>
+  </p:cSld>
+  <p:clrMapOvr>
+    <a:masterClrMapping/>
+  </p:clrMapOvr>
+</p:notes>
+</file>
+
+<file path=ppt/notesSlides/notesSlide22.xml><?xml version="1.0" encoding="utf-8"?>
+<p:notes xmlns:a="http://schemas.openxmlformats.org/drawingml/2006/main" xmlns:r="http://schemas.openxmlformats.org/officeDocument/2006/relationships" xmlns:p="http://schemas.openxmlformats.org/presentationml/2006/main">
+  <p:cSld>
+    <p:spTree>
+      <p:nvGrpSpPr>
+        <p:cNvPr id="1" name=""/>
+        <p:cNvGrpSpPr/>
+        <p:nvPr/>
+      </p:nvGrpSpPr>
+      <p:grpSpPr>
+        <a:xfrm>
+          <a:off x="0" y="0"/>
+          <a:ext cx="0" cy="0"/>
+          <a:chOff x="0" y="0"/>
+          <a:chExt cx="0" cy="0"/>
+        </a:xfrm>
+      </p:grpSpPr>
+      <p:sp>
+        <p:nvSpPr>
+          <p:cNvPr id="2" name="슬라이드 이미지 개체 틀 1"/>
+          <p:cNvSpPr>
+            <a:spLocks noGrp="1" noRot="1" noChangeAspect="1"/>
+          </p:cNvSpPr>
+          <p:nvPr>
+            <p:ph type="sldImg"/>
+          </p:nvPr>
+        </p:nvSpPr>
+        <p:spPr/>
+      </p:sp>
+      <p:sp>
+        <p:nvSpPr>
+          <p:cNvPr id="3" name="슬라이드 노트 개체 틀 2"/>
+          <p:cNvSpPr>
+            <a:spLocks noGrp="1"/>
+          </p:cNvSpPr>
+          <p:nvPr>
+            <p:ph type="body" idx="1"/>
+          </p:nvPr>
+        </p:nvSpPr>
+        <p:spPr/>
+        <p:txBody>
+          <a:bodyPr/>
+          <a:lstStyle/>
+          <a:p>
+            <a:r>
+              <a:rPr lang="ko-KR" altLang="en-US" dirty="0"/>
+              <a:t>우리가 만들어주는 이름</a:t>
+            </a:r>
+            <a:endParaRPr lang="en-US" altLang="ko-KR" dirty="0"/>
+          </a:p>
+          <a:p>
+            <a:r>
+              <a:rPr lang="ko-KR" altLang="en-US" dirty="0"/>
+              <a:t>지속시간 </a:t>
+            </a:r>
+            <a:r>
+              <a:rPr lang="en-US" altLang="ko-KR" dirty="0"/>
+              <a:t>~s</a:t>
+            </a:r>
+            <a:r>
+              <a:rPr lang="en-US" altLang="ko-KR" baseline="0" dirty="0"/>
+              <a:t> </a:t>
+            </a:r>
+            <a:r>
+              <a:rPr lang="ko-KR" altLang="en-US" baseline="0" dirty="0"/>
+              <a:t>의 몇 초 형태</a:t>
+            </a:r>
+            <a:endParaRPr lang="en-US" altLang="ko-KR" baseline="0" dirty="0"/>
+          </a:p>
+          <a:p>
+            <a:r>
+              <a:rPr lang="ko-KR" altLang="en-US" baseline="0" dirty="0"/>
+              <a:t>진행 형태 </a:t>
+            </a:r>
+            <a:r>
+              <a:rPr lang="en-US" altLang="ko-KR" baseline="0" dirty="0"/>
+              <a:t>: </a:t>
+            </a:r>
+            <a:r>
+              <a:rPr lang="ko-KR" altLang="en-US" baseline="0" dirty="0"/>
+              <a:t>시간 함수</a:t>
+            </a:r>
+            <a:r>
+              <a:rPr lang="en-US" altLang="ko-KR" baseline="0" dirty="0"/>
+              <a:t>, transition </a:t>
+            </a:r>
+            <a:r>
+              <a:rPr lang="ko-KR" altLang="en-US" baseline="0" dirty="0"/>
+              <a:t>의 </a:t>
+            </a:r>
+            <a:r>
+              <a:rPr lang="en-US" altLang="ko-KR" baseline="0" dirty="0"/>
+              <a:t>timing-function</a:t>
+            </a:r>
+            <a:r>
+              <a:rPr lang="ko-KR" altLang="en-US" baseline="0" dirty="0"/>
+              <a:t>과 동일</a:t>
+            </a:r>
+            <a:r>
+              <a:rPr lang="en-US" altLang="ko-KR" baseline="0" dirty="0"/>
+              <a:t>. </a:t>
+            </a:r>
+            <a:r>
+              <a:rPr lang="en-US" altLang="ko-KR" baseline="0" dirty="0" err="1"/>
+              <a:t>animatio</a:t>
+            </a:r>
+            <a:r>
+              <a:rPr lang="ko-KR" altLang="en-US" baseline="0" dirty="0"/>
+              <a:t>의 길이는 </a:t>
+            </a:r>
+            <a:r>
+              <a:rPr lang="en-US" altLang="ko-KR" baseline="0" dirty="0" err="1"/>
+              <a:t>transitio</a:t>
+            </a:r>
+            <a:r>
+              <a:rPr lang="ko-KR" altLang="en-US" baseline="0" dirty="0"/>
+              <a:t>과 다르게 지속 시간이 긴 경우가 많기 때문에 움직임이 </a:t>
+            </a:r>
+            <a:r>
+              <a:rPr lang="en-US" altLang="ko-KR" baseline="0" dirty="0"/>
+              <a:t>timing </a:t>
+            </a:r>
+            <a:r>
+              <a:rPr lang="en-US" altLang="ko-KR" baseline="0" dirty="0" err="1"/>
+              <a:t>functio</a:t>
+            </a:r>
+            <a:r>
+              <a:rPr lang="ko-KR" altLang="en-US" baseline="0" dirty="0"/>
+              <a:t>에 따라서 바뀐다</a:t>
+            </a:r>
+            <a:r>
+              <a:rPr lang="en-US" altLang="ko-KR" baseline="0" dirty="0"/>
+              <a:t>. </a:t>
+            </a:r>
+            <a:r>
+              <a:rPr lang="en-US" altLang="ko-KR" baseline="0" dirty="0" err="1"/>
+              <a:t>animaitio</a:t>
+            </a:r>
+            <a:r>
+              <a:rPr lang="ko-KR" altLang="en-US" baseline="0" dirty="0"/>
+              <a:t>에서의 </a:t>
+            </a:r>
+            <a:r>
+              <a:rPr lang="en-US" altLang="ko-KR" baseline="0" dirty="0"/>
+              <a:t>ease linear </a:t>
+            </a:r>
+            <a:r>
+              <a:rPr lang="ko-KR" altLang="en-US" baseline="0" dirty="0"/>
+              <a:t>등의 시간 함수는 꽤 중요한 역할을 함</a:t>
+            </a:r>
+            <a:endParaRPr lang="en-US" altLang="ko-KR" baseline="0" dirty="0"/>
+          </a:p>
+          <a:p>
+            <a:r>
+              <a:rPr lang="ko-KR" altLang="en-US" dirty="0" err="1"/>
+              <a:t>반복횟수</a:t>
+            </a:r>
+            <a:r>
+              <a:rPr lang="ko-KR" altLang="en-US" dirty="0"/>
+              <a:t> </a:t>
+            </a:r>
+            <a:r>
+              <a:rPr lang="en-US" altLang="ko-KR" dirty="0"/>
+              <a:t>(iteration-count)</a:t>
+            </a:r>
+            <a:endParaRPr lang="ko-KR" altLang="en-US" dirty="0"/>
+          </a:p>
+        </p:txBody>
+      </p:sp>
+      <p:sp>
+        <p:nvSpPr>
+          <p:cNvPr id="4" name="슬라이드 번호 개체 틀 3"/>
+          <p:cNvSpPr>
+            <a:spLocks noGrp="1"/>
+          </p:cNvSpPr>
+          <p:nvPr>
+            <p:ph type="sldNum" sz="quarter" idx="10"/>
+          </p:nvPr>
+        </p:nvSpPr>
+        <p:spPr/>
+        <p:txBody>
+          <a:bodyPr/>
+          <a:lstStyle/>
+          <a:p>
+            <a:fld id="{B4FAD15D-3FC6-4EBB-8A1D-F20C53EB7780}" type="slidenum">
+              <a:rPr lang="ko-KR" altLang="en-US" smtClean="0"/>
+              <a:pPr/>
+              <a:t>25</a:t>
+            </a:fld>
+            <a:endParaRPr lang="ko-KR" altLang="en-US" dirty="0"/>
+          </a:p>
+        </p:txBody>
+      </p:sp>
+    </p:spTree>
+    <p:extLst>
+      <p:ext uri="{BB962C8B-B14F-4D97-AF65-F5344CB8AC3E}">
+        <p14:creationId xmlns:p14="http://schemas.microsoft.com/office/powerpoint/2010/main" val="2638017959"/>
+      </p:ext>
+    </p:extLst>
+  </p:cSld>
+  <p:clrMapOvr>
+    <a:masterClrMapping/>
+  </p:clrMapOvr>
+</p:notes>
+</file>
+
+<file path=ppt/notesSlides/notesSlide23.xml><?xml version="1.0" encoding="utf-8"?>
+<p:notes xmlns:a="http://schemas.openxmlformats.org/drawingml/2006/main" xmlns:r="http://schemas.openxmlformats.org/officeDocument/2006/relationships" xmlns:p="http://schemas.openxmlformats.org/presentationml/2006/main">
+  <p:cSld>
+    <p:spTree>
+      <p:nvGrpSpPr>
+        <p:cNvPr id="1" name=""/>
+        <p:cNvGrpSpPr/>
+        <p:nvPr/>
+      </p:nvGrpSpPr>
+      <p:grpSpPr>
+        <a:xfrm>
+          <a:off x="0" y="0"/>
+          <a:ext cx="0" cy="0"/>
+          <a:chOff x="0" y="0"/>
+          <a:chExt cx="0" cy="0"/>
+        </a:xfrm>
+      </p:grpSpPr>
+      <p:sp>
+        <p:nvSpPr>
+          <p:cNvPr id="2" name="슬라이드 이미지 개체 틀 1"/>
+          <p:cNvSpPr>
+            <a:spLocks noGrp="1" noRot="1" noChangeAspect="1"/>
+          </p:cNvSpPr>
+          <p:nvPr>
+            <p:ph type="sldImg"/>
+          </p:nvPr>
+        </p:nvSpPr>
+        <p:spPr/>
+      </p:sp>
+      <p:sp>
+        <p:nvSpPr>
+          <p:cNvPr id="3" name="슬라이드 노트 개체 틀 2"/>
+          <p:cNvSpPr>
+            <a:spLocks noGrp="1"/>
+          </p:cNvSpPr>
+          <p:nvPr>
+            <p:ph type="body" idx="1"/>
+          </p:nvPr>
+        </p:nvSpPr>
+        <p:spPr/>
+        <p:txBody>
+          <a:bodyPr/>
+          <a:lstStyle/>
+          <a:p>
+            <a:r>
+              <a:rPr lang="ko-KR" altLang="en-US" dirty="0" err="1"/>
+              <a:t>파란글씨</a:t>
+            </a:r>
+            <a:r>
+              <a:rPr lang="ko-KR" altLang="en-US" dirty="0"/>
+              <a:t> 필수 속성 </a:t>
+            </a:r>
+            <a:endParaRPr lang="en-US" altLang="ko-KR" dirty="0"/>
+          </a:p>
+          <a:p>
+            <a:r>
+              <a:rPr lang="ko-KR" altLang="en-US" dirty="0"/>
+              <a:t>까만 글씨 생략 가능 </a:t>
+            </a:r>
+            <a:endParaRPr lang="en-US" altLang="ko-KR" dirty="0"/>
+          </a:p>
+          <a:p>
+            <a:r>
+              <a:rPr lang="en-US" altLang="ko-KR" dirty="0"/>
+              <a:t>Timing-</a:t>
+            </a:r>
+            <a:r>
+              <a:rPr lang="en-US" altLang="ko-KR" dirty="0" err="1"/>
+              <a:t>funciton</a:t>
+            </a:r>
+            <a:r>
+              <a:rPr lang="ko-KR" altLang="en-US" dirty="0"/>
+              <a:t>은 보통 써주지만 </a:t>
+            </a:r>
+            <a:r>
+              <a:rPr lang="en-US" altLang="ko-KR" dirty="0"/>
+              <a:t>delay</a:t>
+            </a:r>
+            <a:r>
+              <a:rPr lang="ko-KR" altLang="en-US" dirty="0"/>
+              <a:t>랑 </a:t>
+            </a:r>
+            <a:r>
+              <a:rPr lang="en-US" altLang="ko-KR" dirty="0"/>
+              <a:t>direction</a:t>
+            </a:r>
+            <a:r>
+              <a:rPr lang="ko-KR" altLang="en-US" dirty="0"/>
+              <a:t>은 안써주는 경우가 </a:t>
+            </a:r>
+            <a:r>
+              <a:rPr lang="ko-KR" altLang="en-US" dirty="0" smtClean="0"/>
+              <a:t>많다</a:t>
+            </a:r>
+            <a:r>
+              <a:rPr lang="en-US" altLang="ko-KR" dirty="0" smtClean="0"/>
+              <a:t>!</a:t>
+            </a:r>
+            <a:endParaRPr lang="ko-KR" altLang="en-US" dirty="0"/>
+          </a:p>
+        </p:txBody>
+      </p:sp>
+      <p:sp>
+        <p:nvSpPr>
+          <p:cNvPr id="4" name="슬라이드 번호 개체 틀 3"/>
+          <p:cNvSpPr>
+            <a:spLocks noGrp="1"/>
+          </p:cNvSpPr>
+          <p:nvPr>
+            <p:ph type="sldNum" sz="quarter" idx="10"/>
+          </p:nvPr>
+        </p:nvSpPr>
+        <p:spPr/>
+        <p:txBody>
+          <a:bodyPr/>
+          <a:lstStyle/>
+          <a:p>
+            <a:fld id="{B4FAD15D-3FC6-4EBB-8A1D-F20C53EB7780}" type="slidenum">
+              <a:rPr lang="ko-KR" altLang="en-US" smtClean="0"/>
+              <a:t>26</a:t>
+            </a:fld>
+            <a:endParaRPr lang="ko-KR" altLang="en-US"/>
+          </a:p>
+        </p:txBody>
+      </p:sp>
+    </p:spTree>
+    <p:extLst>
+      <p:ext uri="{BB962C8B-B14F-4D97-AF65-F5344CB8AC3E}">
+        <p14:creationId xmlns:p14="http://schemas.microsoft.com/office/powerpoint/2010/main" val="2277054390"/>
+      </p:ext>
+    </p:extLst>
+  </p:cSld>
+  <p:clrMapOvr>
+    <a:masterClrMapping/>
+  </p:clrMapOvr>
+</p:notes>
+</file>
+
+<file path=ppt/notesSlides/notesSlide24.xml><?xml version="1.0" encoding="utf-8"?>
+<p:notes xmlns:a="http://schemas.openxmlformats.org/drawingml/2006/main" xmlns:r="http://schemas.openxmlformats.org/officeDocument/2006/relationships" xmlns:p="http://schemas.openxmlformats.org/presentationml/2006/main">
+  <p:cSld>
+    <p:spTree>
+      <p:nvGrpSpPr>
+        <p:cNvPr id="1" name=""/>
+        <p:cNvGrpSpPr/>
+        <p:nvPr/>
+      </p:nvGrpSpPr>
+      <p:grpSpPr>
+        <a:xfrm>
+          <a:off x="0" y="0"/>
+          <a:ext cx="0" cy="0"/>
+          <a:chOff x="0" y="0"/>
+          <a:chExt cx="0" cy="0"/>
+        </a:xfrm>
+      </p:grpSpPr>
+      <p:sp>
+        <p:nvSpPr>
+          <p:cNvPr id="2" name="슬라이드 이미지 개체 틀 1"/>
+          <p:cNvSpPr>
+            <a:spLocks noGrp="1" noRot="1" noChangeAspect="1"/>
+          </p:cNvSpPr>
+          <p:nvPr>
+            <p:ph type="sldImg"/>
+          </p:nvPr>
+        </p:nvSpPr>
+        <p:spPr/>
+      </p:sp>
+      <p:sp>
+        <p:nvSpPr>
+          <p:cNvPr id="3" name="슬라이드 노트 개체 틀 2"/>
+          <p:cNvSpPr>
+            <a:spLocks noGrp="1"/>
+          </p:cNvSpPr>
+          <p:nvPr>
+            <p:ph type="body" idx="1"/>
+          </p:nvPr>
+        </p:nvSpPr>
+        <p:spPr/>
+        <p:txBody>
+          <a:bodyPr/>
+          <a:lstStyle/>
+          <a:p>
+            <a:r>
+              <a:rPr lang="ko-KR" altLang="en-US" dirty="0" smtClean="0"/>
+              <a:t>코드 치러 </a:t>
+            </a:r>
+            <a:r>
+              <a:rPr lang="ko-KR" altLang="en-US" dirty="0" err="1" smtClean="0"/>
+              <a:t>ㄱㄱ</a:t>
+            </a:r>
+            <a:endParaRPr lang="ko-KR" altLang="en-US" dirty="0"/>
+          </a:p>
+          <a:p>
+            <a:endParaRPr lang="ko-KR" altLang="en-US" dirty="0"/>
+          </a:p>
+          <a:p>
+            <a:pPr marL="0" marR="0" lvl="0" indent="0" algn="l" defTabSz="914400" rtl="0" eaLnBrk="1" fontAlgn="auto" latinLnBrk="1" hangingPunct="1">
+              <a:lnSpc>
+                <a:spcPct val="100000"/>
+              </a:lnSpc>
+              <a:spcBef>
+                <a:spcPts val="0"/>
+              </a:spcBef>
+              <a:spcAft>
+                <a:spcPts val="0"/>
+              </a:spcAft>
+              <a:buClrTx/>
+              <a:buSzTx/>
+              <a:buFontTx/>
+              <a:buNone/>
+              <a:tabLst/>
+              <a:defRPr/>
+            </a:pPr>
+            <a:endParaRPr lang="en-US" altLang="ko-KR" dirty="0"/>
+          </a:p>
+          <a:p>
+            <a:endParaRPr lang="ko-KR" altLang="en-US" dirty="0"/>
+          </a:p>
+          <a:p>
+            <a:endParaRPr lang="ko-KR" altLang="en-US" dirty="0"/>
+          </a:p>
+          <a:p>
+            <a:endParaRPr lang="ko-KR" altLang="en-US" dirty="0"/>
+          </a:p>
+          <a:p>
+            <a:endParaRPr lang="ko-KR" altLang="en-US" dirty="0"/>
+          </a:p>
+        </p:txBody>
+      </p:sp>
+      <p:sp>
+        <p:nvSpPr>
+          <p:cNvPr id="4" name="슬라이드 번호 개체 틀 3"/>
+          <p:cNvSpPr>
+            <a:spLocks noGrp="1"/>
+          </p:cNvSpPr>
+          <p:nvPr>
+            <p:ph type="sldNum" sz="quarter" idx="5"/>
+          </p:nvPr>
+        </p:nvSpPr>
+        <p:spPr/>
+        <p:txBody>
+          <a:bodyPr/>
+          <a:lstStyle/>
+          <a:p>
+            <a:fld id="{C09E5BFC-1559-42F1-8940-AB342D56BF02}" type="slidenum">
+              <a:rPr lang="ko-KR" altLang="en-US" smtClean="0"/>
+              <a:t>27</a:t>
+            </a:fld>
+            <a:endParaRPr lang="ko-KR" altLang="en-US"/>
+          </a:p>
+        </p:txBody>
+      </p:sp>
+    </p:spTree>
+    <p:extLst>
+      <p:ext uri="{BB962C8B-B14F-4D97-AF65-F5344CB8AC3E}">
+        <p14:creationId xmlns:p14="http://schemas.microsoft.com/office/powerpoint/2010/main" val="3704610732"/>
+      </p:ext>
+    </p:extLst>
+  </p:cSld>
+  <p:clrMapOvr>
+    <a:masterClrMapping/>
+  </p:clrMapOvr>
+</p:notes>
+</file>
+
+<file path=ppt/notesSlides/notesSlide25.xml><?xml version="1.0" encoding="utf-8"?>
+<p:notes xmlns:a="http://schemas.openxmlformats.org/drawingml/2006/main" xmlns:r="http://schemas.openxmlformats.org/officeDocument/2006/relationships" xmlns:p="http://schemas.openxmlformats.org/presentationml/2006/main">
+  <p:cSld>
+    <p:spTree>
+      <p:nvGrpSpPr>
+        <p:cNvPr id="1" name=""/>
+        <p:cNvGrpSpPr/>
+        <p:nvPr/>
+      </p:nvGrpSpPr>
+      <p:grpSpPr>
+        <a:xfrm>
+          <a:off x="0" y="0"/>
+          <a:ext cx="0" cy="0"/>
+          <a:chOff x="0" y="0"/>
+          <a:chExt cx="0" cy="0"/>
+        </a:xfrm>
+      </p:grpSpPr>
+      <p:sp>
+        <p:nvSpPr>
+          <p:cNvPr id="2" name="슬라이드 이미지 개체 틀 1"/>
+          <p:cNvSpPr>
+            <a:spLocks noGrp="1" noRot="1" noChangeAspect="1"/>
+          </p:cNvSpPr>
+          <p:nvPr>
+            <p:ph type="sldImg"/>
+          </p:nvPr>
+        </p:nvSpPr>
+        <p:spPr/>
+      </p:sp>
+      <p:sp>
+        <p:nvSpPr>
+          <p:cNvPr id="3" name="슬라이드 노트 개체 틀 2"/>
+          <p:cNvSpPr>
+            <a:spLocks noGrp="1"/>
+          </p:cNvSpPr>
+          <p:nvPr>
+            <p:ph type="body" idx="1"/>
+          </p:nvPr>
+        </p:nvSpPr>
+        <p:spPr/>
+        <p:txBody>
+          <a:bodyPr/>
+          <a:lstStyle/>
+          <a:p>
             <a:endParaRPr lang="en-US" altLang="ko-KR" b="0" dirty="0">
               <a:solidFill>
                 <a:srgbClr val="D4D4D4"/>
@@ -2975,7 +3114,7 @@
           <a:p>
             <a:fld id="{C09E5BFC-1559-42F1-8940-AB342D56BF02}" type="slidenum">
               <a:rPr lang="ko-KR" altLang="en-US" smtClean="0"/>
-              <a:t>26</a:t>
+              <a:t>29</a:t>
             </a:fld>
             <a:endParaRPr lang="ko-KR" altLang="en-US"/>
           </a:p>
@@ -4210,7 +4349,7 @@
           <p:nvPr userDrawn="1"/>
         </p:nvPicPr>
         <p:blipFill>
-          <a:blip r:embed="rId2">
+          <a:blip r:embed="rId2" cstate="hqprint">
             <a:alphaModFix amt="20000"/>
             <a:extLst>
               <a:ext uri="{28A0092B-C50C-407E-A947-70E740481C1C}">
@@ -7427,7 +7566,7 @@
           <p:nvPr userDrawn="1"/>
         </p:nvPicPr>
         <p:blipFill>
-          <a:blip r:embed="rId15">
+          <a:blip r:embed="rId15" cstate="hqprint">
             <a:extLst>
               <a:ext uri="{28A0092B-C50C-407E-A947-70E740481C1C}">
                 <a14:useLocalDpi xmlns:a14="http://schemas.microsoft.com/office/drawing/2010/main" val="0"/>
@@ -8012,7 +8151,7 @@
           <a:p>
             <a:fld id="{0F78D9C4-20C1-4B15-A116-16DC77AD9A1E}" type="datetime1">
               <a:rPr lang="ko-KR" altLang="en-US" smtClean="0"/>
-              <a:t>2024-05-20</a:t>
+              <a:t>2024-05-24</a:t>
             </a:fld>
             <a:endParaRPr lang="ko-KR" altLang="en-US"/>
           </a:p>
@@ -8300,7 +8439,7 @@
           <a:p>
             <a:fld id="{0F78D9C4-20C1-4B15-A116-16DC77AD9A1E}" type="datetime1">
               <a:rPr lang="ko-KR" altLang="en-US" smtClean="0"/>
-              <a:t>2024-05-20</a:t>
+              <a:t>2024-05-24</a:t>
             </a:fld>
             <a:endParaRPr lang="ko-KR" altLang="en-US" dirty="0"/>
           </a:p>
@@ -9252,7 +9391,7 @@
           <a:p>
             <a:fld id="{0F78D9C4-20C1-4B15-A116-16DC77AD9A1E}" type="datetime1">
               <a:rPr lang="ko-KR" altLang="en-US" smtClean="0"/>
-              <a:t>2024-05-20</a:t>
+              <a:t>2024-05-24</a:t>
             </a:fld>
             <a:endParaRPr lang="ko-KR" altLang="en-US"/>
           </a:p>
@@ -9482,7 +9621,7 @@
           <a:p>
             <a:fld id="{0F78D9C4-20C1-4B15-A116-16DC77AD9A1E}" type="datetime1">
               <a:rPr lang="ko-KR" altLang="en-US" smtClean="0"/>
-              <a:t>2024-05-20</a:t>
+              <a:t>2024-05-24</a:t>
             </a:fld>
             <a:endParaRPr lang="ko-KR" altLang="en-US"/>
           </a:p>
@@ -10517,8 +10656,8 @@
         </p:nvSpPr>
         <p:spPr>
           <a:xfrm>
-            <a:off x="4721087" y="1573833"/>
-            <a:ext cx="3654286" cy="4351338"/>
+            <a:off x="2183363" y="2631233"/>
+            <a:ext cx="7688425" cy="3425044"/>
           </a:xfrm>
         </p:spPr>
         <p:txBody>
@@ -10527,46 +10666,45 @@
           </a:bodyPr>
           <a:lstStyle/>
           <a:p>
+            <a:pPr algn="ctr"/>
             <a:r>
               <a:rPr lang="en-US" altLang="ko-KR" dirty="0"/>
               <a:t>inline / block</a:t>
             </a:r>
           </a:p>
           <a:p>
+            <a:pPr algn="ctr"/>
             <a:endParaRPr lang="en-US" altLang="ko-KR" dirty="0"/>
           </a:p>
           <a:p>
+            <a:pPr algn="ctr"/>
             <a:r>
               <a:rPr lang="en-US" altLang="ko-KR" dirty="0"/>
               <a:t>inline-block</a:t>
             </a:r>
           </a:p>
           <a:p>
+            <a:pPr algn="ctr"/>
             <a:endParaRPr lang="en-US" altLang="ko-KR" dirty="0"/>
           </a:p>
           <a:p>
-            <a:r>
-              <a:rPr lang="en-US" altLang="ko-KR" dirty="0"/>
+            <a:pPr algn="ctr"/>
+            <a:r>
+              <a:rPr lang="en-US" altLang="ko-KR" dirty="0" smtClean="0"/>
               <a:t>flex</a:t>
             </a:r>
           </a:p>
           <a:p>
+            <a:pPr algn="ctr"/>
             <a:endParaRPr lang="en-US" altLang="ko-KR" dirty="0"/>
           </a:p>
           <a:p>
-            <a:r>
-              <a:rPr lang="en-US" altLang="ko-KR" dirty="0"/>
+            <a:pPr algn="ctr"/>
+            <a:r>
+              <a:rPr lang="en-US" altLang="ko-KR" dirty="0" smtClean="0"/>
               <a:t>grid</a:t>
             </a:r>
-          </a:p>
-          <a:p>
             <a:endParaRPr lang="en-US" altLang="ko-KR" dirty="0"/>
-          </a:p>
-          <a:p>
-            <a:r>
-              <a:rPr lang="en-US" altLang="ko-KR" dirty="0"/>
-              <a:t>grid</a:t>
-            </a:r>
           </a:p>
         </p:txBody>
       </p:sp>
@@ -10593,7 +10731,7 @@
           <a:p>
             <a:fld id="{0F78D9C4-20C1-4B15-A116-16DC77AD9A1E}" type="datetime1">
               <a:rPr lang="ko-KR" altLang="en-US" smtClean="0"/>
-              <a:t>2024-05-20</a:t>
+              <a:t>2024-05-24</a:t>
             </a:fld>
             <a:endParaRPr lang="ko-KR" altLang="en-US"/>
           </a:p>
@@ -10695,42 +10833,70 @@
           <a:chExt cx="0" cy="0"/>
         </a:xfrm>
       </p:grpSpPr>
-      <p:pic>
-        <p:nvPicPr>
-          <p:cNvPr id="3" name="그림 2"/>
-          <p:cNvPicPr>
-            <a:picLocks noChangeAspect="1"/>
-          </p:cNvPicPr>
-          <p:nvPr/>
-        </p:nvPicPr>
-        <p:blipFill>
-          <a:blip r:embed="rId3">
-            <a:extLst>
-              <a:ext uri="{28A0092B-C50C-407E-A947-70E740481C1C}">
-                <a14:useLocalDpi xmlns:a14="http://schemas.microsoft.com/office/drawing/2010/main" val="0"/>
-              </a:ext>
-            </a:extLst>
-          </a:blip>
-          <a:stretch>
-            <a:fillRect/>
-          </a:stretch>
-        </p:blipFill>
-        <p:spPr>
-          <a:xfrm>
-            <a:off x="920261" y="1565213"/>
-            <a:ext cx="10351478" cy="4548585"/>
-          </a:xfrm>
-          <a:prstGeom prst="rect">
-            <a:avLst/>
-          </a:prstGeom>
-        </p:spPr>
-      </p:pic>
-      <p:sp>
-        <p:nvSpPr>
-          <p:cNvPr id="2" name="제목 1">
-            <a:extLst>
-              <a:ext uri="{FF2B5EF4-FFF2-40B4-BE49-F238E27FC236}">
-                <a16:creationId xmlns:a16="http://schemas.microsoft.com/office/drawing/2014/main" id="{2281EE9B-083C-1657-437D-D3E4A1E0D007}"/>
+      <p:sp>
+        <p:nvSpPr>
+          <p:cNvPr id="2" name="날짜 개체 틀 1">
+            <a:extLst>
+              <a:ext uri="{FF2B5EF4-FFF2-40B4-BE49-F238E27FC236}">
+                <a16:creationId xmlns:a16="http://schemas.microsoft.com/office/drawing/2014/main" id="{55BDFA10-ECF7-38FE-C364-618B7085F1E3}"/>
+              </a:ext>
+            </a:extLst>
+          </p:cNvPr>
+          <p:cNvSpPr>
+            <a:spLocks noGrp="1"/>
+          </p:cNvSpPr>
+          <p:nvPr>
+            <p:ph type="dt" sz="half" idx="10"/>
+          </p:nvPr>
+        </p:nvSpPr>
+        <p:spPr/>
+        <p:txBody>
+          <a:bodyPr/>
+          <a:lstStyle/>
+          <a:p>
+            <a:fld id="{0E19CB95-6D28-40F1-9DA3-1BAC5D4B5B4F}" type="datetime6">
+              <a:rPr lang="ko-KR" altLang="en-US" smtClean="0"/>
+              <a:t>2024년 5월</a:t>
+            </a:fld>
+            <a:endParaRPr lang="ko-KR" altLang="en-US"/>
+          </a:p>
+        </p:txBody>
+      </p:sp>
+      <p:sp>
+        <p:nvSpPr>
+          <p:cNvPr id="3" name="슬라이드 번호 개체 틀 2">
+            <a:extLst>
+              <a:ext uri="{FF2B5EF4-FFF2-40B4-BE49-F238E27FC236}">
+                <a16:creationId xmlns:a16="http://schemas.microsoft.com/office/drawing/2014/main" id="{BEAC1192-3240-5090-C940-3FE8EE2E796E}"/>
+              </a:ext>
+            </a:extLst>
+          </p:cNvPr>
+          <p:cNvSpPr>
+            <a:spLocks noGrp="1"/>
+          </p:cNvSpPr>
+          <p:nvPr>
+            <p:ph type="sldNum" sz="quarter" idx="12"/>
+          </p:nvPr>
+        </p:nvSpPr>
+        <p:spPr/>
+        <p:txBody>
+          <a:bodyPr/>
+          <a:lstStyle/>
+          <a:p>
+            <a:fld id="{083A2CE0-18CD-4102-B738-4ACFF9E68BA4}" type="slidenum">
+              <a:rPr lang="ko-KR" altLang="en-US" smtClean="0"/>
+              <a:t>19</a:t>
+            </a:fld>
+            <a:endParaRPr lang="ko-KR" altLang="en-US"/>
+          </a:p>
+        </p:txBody>
+      </p:sp>
+      <p:sp>
+        <p:nvSpPr>
+          <p:cNvPr id="4" name="제목 3">
+            <a:extLst>
+              <a:ext uri="{FF2B5EF4-FFF2-40B4-BE49-F238E27FC236}">
+                <a16:creationId xmlns:a16="http://schemas.microsoft.com/office/drawing/2014/main" id="{45DC42BC-3382-7592-84ED-A0A40D69B177}"/>
               </a:ext>
             </a:extLst>
           </p:cNvPr>
@@ -10747,28 +10913,23 @@
           <a:lstStyle/>
           <a:p>
             <a:r>
-              <a:rPr lang="ko-KR" altLang="en-US" dirty="0">
-                <a:solidFill>
-                  <a:srgbClr val="6EC173"/>
-                </a:solidFill>
-              </a:rPr>
-              <a:t>실습</a:t>
-            </a:r>
-            <a:r>
-              <a:rPr lang="en-US" altLang="ko-KR" dirty="0">
-                <a:solidFill>
-                  <a:srgbClr val="6EC173"/>
-                </a:solidFill>
-              </a:rPr>
-              <a:t>. </a:t>
-            </a:r>
-            <a:r>
-              <a:rPr lang="ko-KR" altLang="en-US" dirty="0"/>
-              <a:t>다양한 헤더 만들기 </a:t>
-            </a:r>
-            <a:r>
-              <a:rPr lang="en-US" altLang="ko-KR" dirty="0"/>
-              <a:t>(with. flex)</a:t>
+              <a:rPr lang="ko-KR" altLang="en-US" dirty="0" smtClean="0"/>
+              <a:t>요소를 숨기는 </a:t>
+            </a:r>
+            <a:r>
+              <a:rPr lang="en-US" altLang="ko-KR" dirty="0" smtClean="0"/>
+              <a:t/>
+            </a:r>
+            <a:br>
+              <a:rPr lang="en-US" altLang="ko-KR" dirty="0" smtClean="0"/>
+            </a:br>
+            <a:r>
+              <a:rPr lang="en-US" altLang="ko-KR" dirty="0" smtClean="0"/>
+              <a:t>3</a:t>
+            </a:r>
+            <a:r>
+              <a:rPr lang="ko-KR" altLang="en-US" dirty="0" smtClean="0"/>
+              <a:t>가지 속성</a:t>
             </a:r>
             <a:endParaRPr lang="ko-KR" altLang="en-US" dirty="0"/>
           </a:p>
@@ -10777,7 +10938,7 @@
     </p:spTree>
     <p:extLst>
       <p:ext uri="{BB962C8B-B14F-4D97-AF65-F5344CB8AC3E}">
-        <p14:creationId xmlns:p14="http://schemas.microsoft.com/office/powerpoint/2010/main" val="3887244353"/>
+        <p14:creationId xmlns:p14="http://schemas.microsoft.com/office/powerpoint/2010/main" val="529591250"/>
       </p:ext>
     </p:extLst>
   </p:cSld>
@@ -10908,6 +11069,349 @@
       </p:grpSpPr>
       <p:sp>
         <p:nvSpPr>
+          <p:cNvPr id="3" name="날짜 개체 틀 2"/>
+          <p:cNvSpPr>
+            <a:spLocks noGrp="1"/>
+          </p:cNvSpPr>
+          <p:nvPr>
+            <p:ph type="dt" sz="half" idx="10"/>
+          </p:nvPr>
+        </p:nvSpPr>
+        <p:spPr/>
+        <p:txBody>
+          <a:bodyPr/>
+          <a:lstStyle/>
+          <a:p>
+            <a:fld id="{3C9CE3CE-253F-4F9D-BA15-C226C8D8501E}" type="datetime6">
+              <a:rPr lang="ko-KR" altLang="en-US" smtClean="0"/>
+              <a:t>2024년 5월</a:t>
+            </a:fld>
+            <a:endParaRPr lang="ko-KR" altLang="en-US"/>
+          </a:p>
+        </p:txBody>
+      </p:sp>
+      <p:sp>
+        <p:nvSpPr>
+          <p:cNvPr id="4" name="슬라이드 번호 개체 틀 3"/>
+          <p:cNvSpPr>
+            <a:spLocks noGrp="1"/>
+          </p:cNvSpPr>
+          <p:nvPr>
+            <p:ph type="sldNum" sz="quarter" idx="12"/>
+          </p:nvPr>
+        </p:nvSpPr>
+        <p:spPr/>
+        <p:txBody>
+          <a:bodyPr/>
+          <a:lstStyle/>
+          <a:p>
+            <a:fld id="{083A2CE0-18CD-4102-B738-4ACFF9E68BA4}" type="slidenum">
+              <a:rPr lang="ko-KR" altLang="en-US" smtClean="0"/>
+              <a:t>20</a:t>
+            </a:fld>
+            <a:endParaRPr lang="ko-KR" altLang="en-US"/>
+          </a:p>
+        </p:txBody>
+      </p:sp>
+      <p:pic>
+        <p:nvPicPr>
+          <p:cNvPr id="1026" name="Picture 2" descr="https://blog.kakaocdn.net/dn/b12xKr/btszwcGkMe2/hCyN9XhQn8ovfcR4q8Lp61/img.png"/>
+          <p:cNvPicPr>
+            <a:picLocks noChangeAspect="1" noChangeArrowheads="1"/>
+          </p:cNvPicPr>
+          <p:nvPr/>
+        </p:nvPicPr>
+        <p:blipFill>
+          <a:blip r:embed="rId3">
+            <a:extLst>
+              <a:ext uri="{28A0092B-C50C-407E-A947-70E740481C1C}">
+                <a14:useLocalDpi xmlns:a14="http://schemas.microsoft.com/office/drawing/2010/main" val="0"/>
+              </a:ext>
+            </a:extLst>
+          </a:blip>
+          <a:srcRect/>
+          <a:stretch>
+            <a:fillRect/>
+          </a:stretch>
+        </p:blipFill>
+        <p:spPr bwMode="auto">
+          <a:xfrm>
+            <a:off x="1884784" y="773581"/>
+            <a:ext cx="8763454" cy="5323360"/>
+          </a:xfrm>
+          <a:prstGeom prst="rect">
+            <a:avLst/>
+          </a:prstGeom>
+          <a:noFill/>
+          <a:extLst>
+            <a:ext uri="{909E8E84-426E-40DD-AFC4-6F175D3DCCD1}">
+              <a14:hiddenFill xmlns:a14="http://schemas.microsoft.com/office/drawing/2010/main">
+                <a:solidFill>
+                  <a:srgbClr val="FFFFFF"/>
+                </a:solidFill>
+              </a14:hiddenFill>
+            </a:ext>
+          </a:extLst>
+        </p:spPr>
+      </p:pic>
+    </p:spTree>
+    <p:extLst>
+      <p:ext uri="{BB962C8B-B14F-4D97-AF65-F5344CB8AC3E}">
+        <p14:creationId xmlns:p14="http://schemas.microsoft.com/office/powerpoint/2010/main" val="1268411816"/>
+      </p:ext>
+    </p:extLst>
+  </p:cSld>
+  <p:clrMapOvr>
+    <a:masterClrMapping/>
+  </p:clrMapOvr>
+</p:sld>
+</file>
+
+<file path=ppt/slides/slide21.xml><?xml version="1.0" encoding="utf-8"?>
+<p:sld xmlns:a="http://schemas.openxmlformats.org/drawingml/2006/main" xmlns:r="http://schemas.openxmlformats.org/officeDocument/2006/relationships" xmlns:p="http://schemas.openxmlformats.org/presentationml/2006/main">
+  <p:cSld>
+    <p:spTree>
+      <p:nvGrpSpPr>
+        <p:cNvPr id="1" name=""/>
+        <p:cNvGrpSpPr/>
+        <p:nvPr/>
+      </p:nvGrpSpPr>
+      <p:grpSpPr>
+        <a:xfrm>
+          <a:off x="0" y="0"/>
+          <a:ext cx="0" cy="0"/>
+          <a:chOff x="0" y="0"/>
+          <a:chExt cx="0" cy="0"/>
+        </a:xfrm>
+      </p:grpSpPr>
+      <p:pic>
+        <p:nvPicPr>
+          <p:cNvPr id="3" name="그림 2"/>
+          <p:cNvPicPr>
+            <a:picLocks noChangeAspect="1"/>
+          </p:cNvPicPr>
+          <p:nvPr/>
+        </p:nvPicPr>
+        <p:blipFill>
+          <a:blip r:embed="rId3">
+            <a:extLst>
+              <a:ext uri="{28A0092B-C50C-407E-A947-70E740481C1C}">
+                <a14:useLocalDpi xmlns:a14="http://schemas.microsoft.com/office/drawing/2010/main" val="0"/>
+              </a:ext>
+            </a:extLst>
+          </a:blip>
+          <a:stretch>
+            <a:fillRect/>
+          </a:stretch>
+        </p:blipFill>
+        <p:spPr>
+          <a:xfrm>
+            <a:off x="920261" y="1565213"/>
+            <a:ext cx="10351478" cy="4548585"/>
+          </a:xfrm>
+          <a:prstGeom prst="rect">
+            <a:avLst/>
+          </a:prstGeom>
+        </p:spPr>
+      </p:pic>
+      <p:sp>
+        <p:nvSpPr>
+          <p:cNvPr id="2" name="제목 1">
+            <a:extLst>
+              <a:ext uri="{FF2B5EF4-FFF2-40B4-BE49-F238E27FC236}">
+                <a16:creationId xmlns:a16="http://schemas.microsoft.com/office/drawing/2014/main" id="{2281EE9B-083C-1657-437D-D3E4A1E0D007}"/>
+              </a:ext>
+            </a:extLst>
+          </p:cNvPr>
+          <p:cNvSpPr>
+            <a:spLocks noGrp="1"/>
+          </p:cNvSpPr>
+          <p:nvPr>
+            <p:ph type="title"/>
+          </p:nvPr>
+        </p:nvSpPr>
+        <p:spPr/>
+        <p:txBody>
+          <a:bodyPr/>
+          <a:lstStyle/>
+          <a:p>
+            <a:r>
+              <a:rPr lang="ko-KR" altLang="en-US" dirty="0">
+                <a:solidFill>
+                  <a:srgbClr val="6EC173"/>
+                </a:solidFill>
+              </a:rPr>
+              <a:t>실습</a:t>
+            </a:r>
+            <a:r>
+              <a:rPr lang="en-US" altLang="ko-KR" dirty="0">
+                <a:solidFill>
+                  <a:srgbClr val="6EC173"/>
+                </a:solidFill>
+              </a:rPr>
+              <a:t>. </a:t>
+            </a:r>
+            <a:r>
+              <a:rPr lang="ko-KR" altLang="en-US" dirty="0"/>
+              <a:t>다양한 헤더 만들기 </a:t>
+            </a:r>
+            <a:r>
+              <a:rPr lang="en-US" altLang="ko-KR" dirty="0"/>
+              <a:t>(with. flex)</a:t>
+            </a:r>
+            <a:endParaRPr lang="ko-KR" altLang="en-US" dirty="0"/>
+          </a:p>
+        </p:txBody>
+      </p:sp>
+    </p:spTree>
+    <p:extLst>
+      <p:ext uri="{BB962C8B-B14F-4D97-AF65-F5344CB8AC3E}">
+        <p14:creationId xmlns:p14="http://schemas.microsoft.com/office/powerpoint/2010/main" val="3887244353"/>
+      </p:ext>
+    </p:extLst>
+  </p:cSld>
+  <p:clrMapOvr>
+    <a:masterClrMapping/>
+  </p:clrMapOvr>
+</p:sld>
+</file>
+
+<file path=ppt/slides/slide22.xml><?xml version="1.0" encoding="utf-8"?>
+<p:sld xmlns:a="http://schemas.openxmlformats.org/drawingml/2006/main" xmlns:r="http://schemas.openxmlformats.org/officeDocument/2006/relationships" xmlns:p="http://schemas.openxmlformats.org/presentationml/2006/main">
+  <p:cSld>
+    <p:spTree>
+      <p:nvGrpSpPr>
+        <p:cNvPr id="1" name=""/>
+        <p:cNvGrpSpPr/>
+        <p:nvPr/>
+      </p:nvGrpSpPr>
+      <p:grpSpPr>
+        <a:xfrm>
+          <a:off x="0" y="0"/>
+          <a:ext cx="0" cy="0"/>
+          <a:chOff x="0" y="0"/>
+          <a:chExt cx="0" cy="0"/>
+        </a:xfrm>
+      </p:grpSpPr>
+      <p:sp>
+        <p:nvSpPr>
+          <p:cNvPr id="2" name="날짜 개체 틀 1">
+            <a:extLst>
+              <a:ext uri="{FF2B5EF4-FFF2-40B4-BE49-F238E27FC236}">
+                <a16:creationId xmlns:a16="http://schemas.microsoft.com/office/drawing/2014/main" id="{55BDFA10-ECF7-38FE-C364-618B7085F1E3}"/>
+              </a:ext>
+            </a:extLst>
+          </p:cNvPr>
+          <p:cNvSpPr>
+            <a:spLocks noGrp="1"/>
+          </p:cNvSpPr>
+          <p:nvPr>
+            <p:ph type="dt" sz="half" idx="10"/>
+          </p:nvPr>
+        </p:nvSpPr>
+        <p:spPr/>
+        <p:txBody>
+          <a:bodyPr/>
+          <a:lstStyle/>
+          <a:p>
+            <a:fld id="{0E19CB95-6D28-40F1-9DA3-1BAC5D4B5B4F}" type="datetime6">
+              <a:rPr lang="ko-KR" altLang="en-US" smtClean="0"/>
+              <a:t>2024년 5월</a:t>
+            </a:fld>
+            <a:endParaRPr lang="ko-KR" altLang="en-US"/>
+          </a:p>
+        </p:txBody>
+      </p:sp>
+      <p:sp>
+        <p:nvSpPr>
+          <p:cNvPr id="3" name="슬라이드 번호 개체 틀 2">
+            <a:extLst>
+              <a:ext uri="{FF2B5EF4-FFF2-40B4-BE49-F238E27FC236}">
+                <a16:creationId xmlns:a16="http://schemas.microsoft.com/office/drawing/2014/main" id="{BEAC1192-3240-5090-C940-3FE8EE2E796E}"/>
+              </a:ext>
+            </a:extLst>
+          </p:cNvPr>
+          <p:cNvSpPr>
+            <a:spLocks noGrp="1"/>
+          </p:cNvSpPr>
+          <p:nvPr>
+            <p:ph type="sldNum" sz="quarter" idx="12"/>
+          </p:nvPr>
+        </p:nvSpPr>
+        <p:spPr/>
+        <p:txBody>
+          <a:bodyPr/>
+          <a:lstStyle/>
+          <a:p>
+            <a:fld id="{083A2CE0-18CD-4102-B738-4ACFF9E68BA4}" type="slidenum">
+              <a:rPr lang="ko-KR" altLang="en-US" smtClean="0"/>
+              <a:t>22</a:t>
+            </a:fld>
+            <a:endParaRPr lang="ko-KR" altLang="en-US"/>
+          </a:p>
+        </p:txBody>
+      </p:sp>
+      <p:sp>
+        <p:nvSpPr>
+          <p:cNvPr id="4" name="제목 3">
+            <a:extLst>
+              <a:ext uri="{FF2B5EF4-FFF2-40B4-BE49-F238E27FC236}">
+                <a16:creationId xmlns:a16="http://schemas.microsoft.com/office/drawing/2014/main" id="{45DC42BC-3382-7592-84ED-A0A40D69B177}"/>
+              </a:ext>
+            </a:extLst>
+          </p:cNvPr>
+          <p:cNvSpPr>
+            <a:spLocks noGrp="1"/>
+          </p:cNvSpPr>
+          <p:nvPr>
+            <p:ph type="title"/>
+          </p:nvPr>
+        </p:nvSpPr>
+        <p:spPr/>
+        <p:txBody>
+          <a:bodyPr/>
+          <a:lstStyle/>
+          <a:p>
+            <a:r>
+              <a:rPr lang="en-US" altLang="ko-KR" sz="11500" dirty="0" smtClean="0"/>
+              <a:t>animation</a:t>
+            </a:r>
+            <a:endParaRPr lang="ko-KR" altLang="en-US" sz="11500" dirty="0"/>
+          </a:p>
+        </p:txBody>
+      </p:sp>
+    </p:spTree>
+    <p:extLst>
+      <p:ext uri="{BB962C8B-B14F-4D97-AF65-F5344CB8AC3E}">
+        <p14:creationId xmlns:p14="http://schemas.microsoft.com/office/powerpoint/2010/main" val="1010795179"/>
+      </p:ext>
+    </p:extLst>
+  </p:cSld>
+  <p:clrMapOvr>
+    <a:masterClrMapping/>
+  </p:clrMapOvr>
+</p:sld>
+</file>
+
+<file path=ppt/slides/slide23.xml><?xml version="1.0" encoding="utf-8"?>
+<p:sld xmlns:a="http://schemas.openxmlformats.org/drawingml/2006/main" xmlns:r="http://schemas.openxmlformats.org/officeDocument/2006/relationships" xmlns:p="http://schemas.openxmlformats.org/presentationml/2006/main">
+  <p:cSld>
+    <p:spTree>
+      <p:nvGrpSpPr>
+        <p:cNvPr id="1" name=""/>
+        <p:cNvGrpSpPr/>
+        <p:nvPr/>
+      </p:nvGrpSpPr>
+      <p:grpSpPr>
+        <a:xfrm>
+          <a:off x="0" y="0"/>
+          <a:ext cx="0" cy="0"/>
+          <a:chOff x="0" y="0"/>
+          <a:chExt cx="0" cy="0"/>
+        </a:xfrm>
+      </p:grpSpPr>
+      <p:sp>
+        <p:nvSpPr>
           <p:cNvPr id="6" name="내용 개체 틀 6">
             <a:extLst>
               <a:ext uri="{FF2B5EF4-FFF2-40B4-BE49-F238E27FC236}">
@@ -10938,12 +11442,20 @@
               <a:buNone/>
             </a:pPr>
             <a:r>
-              <a:rPr lang="ko-KR" altLang="en-US" dirty="0" err="1"/>
-              <a:t>애니매이션을</a:t>
+              <a:rPr lang="ko-KR" altLang="en-US" dirty="0" smtClean="0"/>
+              <a:t>애니</a:t>
             </a:r>
             <a:r>
               <a:rPr lang="ko-KR" altLang="en-US" dirty="0"/>
-              <a:t> 나타내는 </a:t>
+              <a:t>메</a:t>
+            </a:r>
+            <a:r>
+              <a:rPr lang="ko-KR" altLang="en-US" dirty="0" smtClean="0"/>
+              <a:t>이션을 </a:t>
+            </a:r>
+            <a:r>
+              <a:rPr lang="ko-KR" altLang="en-US" dirty="0"/>
+              <a:t>나타내는 </a:t>
             </a:r>
             <a:r>
               <a:rPr lang="en-US" altLang="ko-KR" dirty="0" err="1"/>
@@ -10977,12 +11489,12 @@
               <a:buNone/>
             </a:pPr>
             <a:r>
-              <a:rPr lang="ko-KR" altLang="en-US" dirty="0" err="1"/>
-              <a:t>애니매이션의</a:t>
+              <a:rPr lang="ko-KR" altLang="en-US" dirty="0" smtClean="0"/>
+              <a:t>애니메이션의 </a:t>
             </a:r>
             <a:r>
               <a:rPr lang="ko-KR" altLang="en-US" dirty="0"/>
-              <a:t> 중간 상태를 나타내는 키 프레임</a:t>
+              <a:t>중간 상태를 나타내는 키 프레임</a:t>
             </a:r>
             <a:endParaRPr lang="en-US" altLang="ko-KR" dirty="0"/>
           </a:p>
@@ -11011,7 +11523,7 @@
           <a:p>
             <a:fld id="{0F78D9C4-20C1-4B15-A116-16DC77AD9A1E}" type="datetime1">
               <a:rPr lang="ko-KR" altLang="en-US" smtClean="0"/>
-              <a:t>2024-05-20</a:t>
+              <a:t>2024-05-24</a:t>
             </a:fld>
             <a:endParaRPr lang="ko-KR" altLang="en-US"/>
           </a:p>
@@ -11040,7 +11552,7 @@
           <a:p>
             <a:fld id="{083A2CE0-18CD-4102-B738-4ACFF9E68BA4}" type="slidenum">
               <a:rPr lang="ko-KR" altLang="en-US" smtClean="0"/>
-              <a:t>20</a:t>
+              <a:t>23</a:t>
             </a:fld>
             <a:endParaRPr lang="ko-KR" altLang="en-US"/>
           </a:p>
@@ -11161,7 +11673,7 @@
 </p:sld>
 </file>
 
-<file path=ppt/slides/slide21.xml><?xml version="1.0" encoding="utf-8"?>
+<file path=ppt/slides/slide24.xml><?xml version="1.0" encoding="utf-8"?>
 <p:sld xmlns:a="http://schemas.openxmlformats.org/drawingml/2006/main" xmlns:r="http://schemas.openxmlformats.org/officeDocument/2006/relationships" xmlns:p="http://schemas.openxmlformats.org/presentationml/2006/main">
   <p:cSld>
     <p:spTree>
@@ -11364,7 +11876,7 @@
 </p:sld>
 </file>
 
-<file path=ppt/slides/slide22.xml><?xml version="1.0" encoding="utf-8"?>
+<file path=ppt/slides/slide25.xml><?xml version="1.0" encoding="utf-8"?>
 <p:sld xmlns:a="http://schemas.openxmlformats.org/drawingml/2006/main" xmlns:r="http://schemas.openxmlformats.org/officeDocument/2006/relationships" xmlns:p="http://schemas.openxmlformats.org/presentationml/2006/main">
   <p:cSld>
     <p:spTree>
@@ -11572,7 +12084,7 @@
 </p:sld>
 </file>
 
-<file path=ppt/slides/slide23.xml><?xml version="1.0" encoding="utf-8"?>
+<file path=ppt/slides/slide26.xml><?xml version="1.0" encoding="utf-8"?>
 <p:sld xmlns:a="http://schemas.openxmlformats.org/drawingml/2006/main" xmlns:r="http://schemas.openxmlformats.org/officeDocument/2006/relationships" xmlns:p="http://schemas.openxmlformats.org/presentationml/2006/main">
   <p:cSld>
     <p:spTree>
@@ -11931,7 +12443,7 @@
         </p:blipFill>
         <p:spPr>
           <a:xfrm>
-            <a:off x="1794587" y="5214968"/>
+            <a:off x="1810540" y="5214968"/>
             <a:ext cx="7597906" cy="429511"/>
           </a:xfrm>
           <a:prstGeom prst="rect">
@@ -12012,7 +12524,7 @@
 </p:sld>
 </file>
 
-<file path=ppt/slides/slide24.xml><?xml version="1.0" encoding="utf-8"?>
+<file path=ppt/slides/slide27.xml><?xml version="1.0" encoding="utf-8"?>
 <p:sld xmlns:a="http://schemas.openxmlformats.org/drawingml/2006/main" xmlns:r="http://schemas.openxmlformats.org/officeDocument/2006/relationships" xmlns:p="http://schemas.openxmlformats.org/presentationml/2006/main">
   <p:cSld>
     <p:spTree>
@@ -12052,7 +12564,7 @@
           <a:p>
             <a:fld id="{0F78D9C4-20C1-4B15-A116-16DC77AD9A1E}" type="datetime1">
               <a:rPr lang="ko-KR" altLang="en-US" smtClean="0"/>
-              <a:t>2024-05-20</a:t>
+              <a:t>2024-05-24</a:t>
             </a:fld>
             <a:endParaRPr lang="ko-KR" altLang="en-US" dirty="0"/>
           </a:p>
@@ -12081,7 +12593,7 @@
           <a:p>
             <a:fld id="{083A2CE0-18CD-4102-B738-4ACFF9E68BA4}" type="slidenum">
               <a:rPr lang="ko-KR" altLang="en-US" smtClean="0"/>
-              <a:t>24</a:t>
+              <a:t>27</a:t>
             </a:fld>
             <a:endParaRPr lang="ko-KR" altLang="en-US"/>
           </a:p>
@@ -12395,7 +12907,7 @@
 </p:sld>
 </file>
 
-<file path=ppt/slides/slide25.xml><?xml version="1.0" encoding="utf-8"?>
+<file path=ppt/slides/slide28.xml><?xml version="1.0" encoding="utf-8"?>
 <p:sld xmlns:a="http://schemas.openxmlformats.org/drawingml/2006/main" xmlns:r="http://schemas.openxmlformats.org/officeDocument/2006/relationships" xmlns:p="http://schemas.openxmlformats.org/presentationml/2006/main">
   <p:cSld>
     <p:spTree>
@@ -12580,7 +13092,7 @@
           <a:p>
             <a:fld id="{0F78D9C4-20C1-4B15-A116-16DC77AD9A1E}" type="datetime1">
               <a:rPr lang="ko-KR" altLang="en-US" smtClean="0"/>
-              <a:t>2024-05-20</a:t>
+              <a:t>2024-05-24</a:t>
             </a:fld>
             <a:endParaRPr lang="ko-KR" altLang="en-US"/>
           </a:p>
@@ -12609,7 +13121,7 @@
           <a:p>
             <a:fld id="{083A2CE0-18CD-4102-B738-4ACFF9E68BA4}" type="slidenum">
               <a:rPr lang="ko-KR" altLang="en-US" smtClean="0"/>
-              <a:t>25</a:t>
+              <a:t>28</a:t>
             </a:fld>
             <a:endParaRPr lang="ko-KR" altLang="en-US"/>
           </a:p>
@@ -12717,7 +13229,7 @@
 </p:sld>
 </file>
 
-<file path=ppt/slides/slide26.xml><?xml version="1.0" encoding="utf-8"?>
+<file path=ppt/slides/slide29.xml><?xml version="1.0" encoding="utf-8"?>
 <p:sld xmlns:a="http://schemas.openxmlformats.org/drawingml/2006/main" xmlns:r="http://schemas.openxmlformats.org/officeDocument/2006/relationships" xmlns:p="http://schemas.openxmlformats.org/presentationml/2006/main">
   <p:cSld>
     <p:spTree>
@@ -12825,7 +13337,7 @@
           <a:p>
             <a:fld id="{0F78D9C4-20C1-4B15-A116-16DC77AD9A1E}" type="datetime1">
               <a:rPr lang="ko-KR" altLang="en-US" smtClean="0"/>
-              <a:t>2024-05-20</a:t>
+              <a:t>2024-05-24</a:t>
             </a:fld>
             <a:endParaRPr lang="ko-KR" altLang="en-US"/>
           </a:p>
@@ -12854,7 +13366,7 @@
           <a:p>
             <a:fld id="{083A2CE0-18CD-4102-B738-4ACFF9E68BA4}" type="slidenum">
               <a:rPr lang="ko-KR" altLang="en-US" smtClean="0"/>
-              <a:t>26</a:t>
+              <a:t>29</a:t>
             </a:fld>
             <a:endParaRPr lang="ko-KR" altLang="en-US"/>
           </a:p>
@@ -13162,7 +13674,7 @@
           <a:p>
             <a:fld id="{0F78D9C4-20C1-4B15-A116-16DC77AD9A1E}" type="datetime1">
               <a:rPr lang="ko-KR" altLang="en-US" smtClean="0"/>
-              <a:t>2024-05-20</a:t>
+              <a:t>2024-05-24</a:t>
             </a:fld>
             <a:endParaRPr lang="ko-KR" altLang="en-US" dirty="0"/>
           </a:p>
@@ -13287,7 +13799,7 @@
           <a:p>
             <a:fld id="{0F78D9C4-20C1-4B15-A116-16DC77AD9A1E}" type="datetime1">
               <a:rPr lang="ko-KR" altLang="en-US" smtClean="0"/>
-              <a:t>2024-05-20</a:t>
+              <a:t>2024-05-24</a:t>
             </a:fld>
             <a:endParaRPr lang="ko-KR" altLang="en-US" dirty="0"/>
           </a:p>
@@ -13402,8 +13914,8 @@
         </p:nvSpPr>
         <p:spPr>
           <a:xfrm>
-            <a:off x="7576151" y="4563466"/>
-            <a:ext cx="3982802" cy="830997"/>
+            <a:off x="7562291" y="5433062"/>
+            <a:ext cx="4367597" cy="830997"/>
           </a:xfrm>
           <a:prstGeom prst="rect">
             <a:avLst/>
@@ -13623,7 +14135,7 @@
           <a:p>
             <a:fld id="{0F78D9C4-20C1-4B15-A116-16DC77AD9A1E}" type="datetime1">
               <a:rPr lang="ko-KR" altLang="en-US" smtClean="0"/>
-              <a:t>2024-05-20</a:t>
+              <a:t>2024-05-24</a:t>
             </a:fld>
             <a:endParaRPr lang="ko-KR" altLang="en-US"/>
           </a:p>
@@ -14161,7 +14673,7 @@
           <a:p>
             <a:fld id="{0F78D9C4-20C1-4B15-A116-16DC77AD9A1E}" type="datetime1">
               <a:rPr lang="ko-KR" altLang="en-US" smtClean="0"/>
-              <a:t>2024-05-20</a:t>
+              <a:t>2024-05-24</a:t>
             </a:fld>
             <a:endParaRPr lang="ko-KR" altLang="en-US"/>
           </a:p>
@@ -14472,7 +14984,7 @@
           <a:p>
             <a:fld id="{0F78D9C4-20C1-4B15-A116-16DC77AD9A1E}" type="datetime1">
               <a:rPr lang="ko-KR" altLang="en-US" smtClean="0"/>
-              <a:t>2024-05-20</a:t>
+              <a:t>2024-05-24</a:t>
             </a:fld>
             <a:endParaRPr lang="ko-KR" altLang="en-US"/>
           </a:p>

</xml_diff>

<commit_message>
Study: CSS 수업 완료!
</commit_message>
<xml_diff>
--- a/material/[SeSAC_YDP_6] 03_CSS_3.pptx
+++ b/material/[SeSAC_YDP_6] 03_CSS_3.pptx
@@ -228,7 +228,7 @@
           <a:p>
             <a:fld id="{00524019-D21D-4F04-AF43-2AEEE922364E}" type="datetimeFigureOut">
               <a:rPr lang="ko-KR" altLang="en-US" smtClean="0"/>
-              <a:t>2024-05-24</a:t>
+              <a:t>2024-05-27</a:t>
             </a:fld>
             <a:endParaRPr lang="ko-KR" altLang="en-US"/>
           </a:p>
@@ -8479,7 +8479,7 @@
           <a:p>
             <a:fld id="{0F78D9C4-20C1-4B15-A116-16DC77AD9A1E}" type="datetime1">
               <a:rPr lang="ko-KR" altLang="en-US" smtClean="0"/>
-              <a:t>2024-05-24</a:t>
+              <a:t>2024-05-27</a:t>
             </a:fld>
             <a:endParaRPr lang="ko-KR" altLang="en-US"/>
           </a:p>
@@ -8766,7 +8766,7 @@
           <a:p>
             <a:fld id="{0F78D9C4-20C1-4B15-A116-16DC77AD9A1E}" type="datetime1">
               <a:rPr lang="ko-KR" altLang="en-US" smtClean="0"/>
-              <a:t>2024-05-24</a:t>
+              <a:t>2024-05-27</a:t>
             </a:fld>
             <a:endParaRPr lang="ko-KR" altLang="en-US"/>
           </a:p>
@@ -9054,7 +9054,7 @@
           <a:p>
             <a:fld id="{0F78D9C4-20C1-4B15-A116-16DC77AD9A1E}" type="datetime1">
               <a:rPr lang="ko-KR" altLang="en-US" smtClean="0"/>
-              <a:t>2024-05-24</a:t>
+              <a:t>2024-05-27</a:t>
             </a:fld>
             <a:endParaRPr lang="ko-KR" altLang="en-US" dirty="0"/>
           </a:p>
@@ -10006,7 +10006,7 @@
           <a:p>
             <a:fld id="{0F78D9C4-20C1-4B15-A116-16DC77AD9A1E}" type="datetime1">
               <a:rPr lang="ko-KR" altLang="en-US" smtClean="0"/>
-              <a:t>2024-05-24</a:t>
+              <a:t>2024-05-27</a:t>
             </a:fld>
             <a:endParaRPr lang="ko-KR" altLang="en-US"/>
           </a:p>
@@ -10221,7 +10221,7 @@
           <a:p>
             <a:fld id="{0F78D9C4-20C1-4B15-A116-16DC77AD9A1E}" type="datetime1">
               <a:rPr lang="ko-KR" altLang="en-US" smtClean="0"/>
-              <a:t>2024-05-24</a:t>
+              <a:t>2024-05-27</a:t>
             </a:fld>
             <a:endParaRPr lang="ko-KR" altLang="en-US"/>
           </a:p>
@@ -10784,7 +10784,7 @@
           <a:p>
             <a:fld id="{0F78D9C4-20C1-4B15-A116-16DC77AD9A1E}" type="datetime1">
               <a:rPr lang="ko-KR" altLang="en-US" smtClean="0"/>
-              <a:t>2024-05-24</a:t>
+              <a:t>2024-05-27</a:t>
             </a:fld>
             <a:endParaRPr lang="ko-KR" altLang="en-US"/>
           </a:p>
@@ -11492,7 +11492,7 @@
           <a:p>
             <a:fld id="{0F78D9C4-20C1-4B15-A116-16DC77AD9A1E}" type="datetime1">
               <a:rPr lang="ko-KR" altLang="en-US" smtClean="0"/>
-              <a:t>2024-05-24</a:t>
+              <a:t>2024-05-27</a:t>
             </a:fld>
             <a:endParaRPr lang="ko-KR" altLang="en-US"/>
           </a:p>
@@ -12004,7 +12004,7 @@
           <a:p>
             <a:fld id="{0F78D9C4-20C1-4B15-A116-16DC77AD9A1E}" type="datetime1">
               <a:rPr lang="ko-KR" altLang="en-US" smtClean="0"/>
-              <a:t>2024-05-24</a:t>
+              <a:t>2024-05-27</a:t>
             </a:fld>
             <a:endParaRPr lang="ko-KR" altLang="en-US"/>
           </a:p>
@@ -12603,7 +12603,7 @@
           <a:p>
             <a:fld id="{0F78D9C4-20C1-4B15-A116-16DC77AD9A1E}" type="datetime1">
               <a:rPr lang="ko-KR" altLang="en-US" smtClean="0"/>
-              <a:t>2024-05-24</a:t>
+              <a:t>2024-05-27</a:t>
             </a:fld>
             <a:endParaRPr lang="ko-KR" altLang="en-US"/>
           </a:p>
@@ -13355,7 +13355,7 @@
           <a:p>
             <a:fld id="{0F78D9C4-20C1-4B15-A116-16DC77AD9A1E}" type="datetime1">
               <a:rPr lang="ko-KR" altLang="en-US" smtClean="0"/>
-              <a:t>2024-05-24</a:t>
+              <a:t>2024-05-27</a:t>
             </a:fld>
             <a:endParaRPr lang="ko-KR" altLang="en-US"/>
           </a:p>
@@ -14396,7 +14396,7 @@
           <a:p>
             <a:fld id="{0F78D9C4-20C1-4B15-A116-16DC77AD9A1E}" type="datetime1">
               <a:rPr lang="ko-KR" altLang="en-US" smtClean="0"/>
-              <a:t>2024-05-24</a:t>
+              <a:t>2024-05-27</a:t>
             </a:fld>
             <a:endParaRPr lang="ko-KR" altLang="en-US" dirty="0"/>
           </a:p>
@@ -14937,7 +14937,7 @@
           <a:p>
             <a:fld id="{0F78D9C4-20C1-4B15-A116-16DC77AD9A1E}" type="datetime1">
               <a:rPr lang="ko-KR" altLang="en-US" smtClean="0"/>
-              <a:t>2024-05-24</a:t>
+              <a:t>2024-05-27</a:t>
             </a:fld>
             <a:endParaRPr lang="ko-KR" altLang="en-US"/>
           </a:p>
@@ -15521,7 +15521,7 @@
           <a:p>
             <a:fld id="{0F78D9C4-20C1-4B15-A116-16DC77AD9A1E}" type="datetime1">
               <a:rPr lang="ko-KR" altLang="en-US" smtClean="0"/>
-              <a:t>2024-05-24</a:t>
+              <a:t>2024-05-27</a:t>
             </a:fld>
             <a:endParaRPr lang="ko-KR" altLang="en-US"/>
           </a:p>
@@ -16064,7 +16064,7 @@
           <a:p>
             <a:fld id="{0F78D9C4-20C1-4B15-A116-16DC77AD9A1E}" type="datetime1">
               <a:rPr lang="ko-KR" altLang="en-US" smtClean="0"/>
-              <a:t>2024-05-24</a:t>
+              <a:t>2024-05-27</a:t>
             </a:fld>
             <a:endParaRPr lang="ko-KR" altLang="en-US"/>
           </a:p>
@@ -16535,7 +16535,7 @@
           <a:p>
             <a:fld id="{0F78D9C4-20C1-4B15-A116-16DC77AD9A1E}" type="datetime1">
               <a:rPr lang="ko-KR" altLang="en-US" smtClean="0"/>
-              <a:t>2024-05-24</a:t>
+              <a:t>2024-05-27</a:t>
             </a:fld>
             <a:endParaRPr lang="ko-KR" altLang="en-US" dirty="0"/>
           </a:p>
@@ -16660,7 +16660,7 @@
           <a:p>
             <a:fld id="{0F78D9C4-20C1-4B15-A116-16DC77AD9A1E}" type="datetime1">
               <a:rPr lang="ko-KR" altLang="en-US" smtClean="0"/>
-              <a:t>2024-05-24</a:t>
+              <a:t>2024-05-27</a:t>
             </a:fld>
             <a:endParaRPr lang="ko-KR" altLang="en-US" dirty="0"/>
           </a:p>
@@ -17486,7 +17486,7 @@
           <a:p>
             <a:fld id="{0F78D9C4-20C1-4B15-A116-16DC77AD9A1E}" type="datetime1">
               <a:rPr lang="ko-KR" altLang="en-US" smtClean="0"/>
-              <a:t>2024-05-24</a:t>
+              <a:t>2024-05-27</a:t>
             </a:fld>
             <a:endParaRPr lang="ko-KR" altLang="en-US"/>
           </a:p>
@@ -18237,7 +18237,7 @@
           <a:p>
             <a:fld id="{0F78D9C4-20C1-4B15-A116-16DC77AD9A1E}" type="datetime1">
               <a:rPr lang="ko-KR" altLang="en-US" smtClean="0"/>
-              <a:t>2024-05-24</a:t>
+              <a:t>2024-05-27</a:t>
             </a:fld>
             <a:endParaRPr lang="ko-KR" altLang="en-US"/>
           </a:p>

</xml_diff>